<commit_message>
docs: improve presentation text readability
</commit_message>
<xml_diff>
--- a/docs/tech-posts/post/tableau-cloud-vs-desktop-feature-diff-summary-en.pptx
+++ b/docs/tech-posts/post/tableau-cloud-vs-desktop-feature-diff-summary-en.pptx
@@ -2,19 +2,19 @@
 <file path=ppt/presentation.xml><?xml version="1.0" encoding="utf-8"?>
 <p:presentation xmlns:p="http://schemas.openxmlformats.org/presentationml/2006/main">
   <p:sldMasterIdLst>
-    <p:sldMasterId xmlns:r="http://schemas.openxmlformats.org/officeDocument/2006/relationships" id="2147483648" r:id="Rc08fd67982dd496a"/>
+    <p:sldMasterId xmlns:r="http://schemas.openxmlformats.org/officeDocument/2006/relationships" id="2147483648" r:id="Rc509b2a8766f4cc0"/>
   </p:sldMasterIdLst>
   <p:notesMasterIdLst>
-    <p:notesMasterId xmlns:r="http://schemas.openxmlformats.org/officeDocument/2006/relationships" r:id="R946d9ec431f94dfa"/>
+    <p:notesMasterId xmlns:r="http://schemas.openxmlformats.org/officeDocument/2006/relationships" r:id="R752c70be474a4178"/>
   </p:notesMasterIdLst>
   <p:sldIdLst>
-    <p:sldId xmlns:r="http://schemas.openxmlformats.org/officeDocument/2006/relationships" id="256" r:id="R390c2bcc7f6543d5"/>
-    <p:sldId xmlns:r="http://schemas.openxmlformats.org/officeDocument/2006/relationships" id="257" r:id="R3f35299920a74ef2"/>
-    <p:sldId xmlns:r="http://schemas.openxmlformats.org/officeDocument/2006/relationships" id="258" r:id="R4b5370db102745d6"/>
-    <p:sldId xmlns:r="http://schemas.openxmlformats.org/officeDocument/2006/relationships" id="259" r:id="Rc12f6cb3ceff4df5"/>
-    <p:sldId xmlns:r="http://schemas.openxmlformats.org/officeDocument/2006/relationships" id="260" r:id="Rf4414618c59e4010"/>
-    <p:sldId xmlns:r="http://schemas.openxmlformats.org/officeDocument/2006/relationships" id="261" r:id="Ra3a7cb588f1c496c"/>
-    <p:sldId xmlns:r="http://schemas.openxmlformats.org/officeDocument/2006/relationships" id="262" r:id="R78f09d3a1a304d4f"/>
+    <p:sldId xmlns:r="http://schemas.openxmlformats.org/officeDocument/2006/relationships" id="256" r:id="Rc856f40c79e7454b"/>
+    <p:sldId xmlns:r="http://schemas.openxmlformats.org/officeDocument/2006/relationships" id="257" r:id="R616fd7180ce5462b"/>
+    <p:sldId xmlns:r="http://schemas.openxmlformats.org/officeDocument/2006/relationships" id="258" r:id="R88757afe5db24117"/>
+    <p:sldId xmlns:r="http://schemas.openxmlformats.org/officeDocument/2006/relationships" id="259" r:id="Rebb4fc8dfcf146ca"/>
+    <p:sldId xmlns:r="http://schemas.openxmlformats.org/officeDocument/2006/relationships" id="260" r:id="Rde866372462f4732"/>
+    <p:sldId xmlns:r="http://schemas.openxmlformats.org/officeDocument/2006/relationships" id="261" r:id="Ra79f934e9b884e9f"/>
+    <p:sldId xmlns:r="http://schemas.openxmlformats.org/officeDocument/2006/relationships" id="262" r:id="R00d5f24c27384100"/>
   </p:sldIdLst>
   <p:sldSz cx="12192000" cy="6858000"/>
   <p:notesSz cx="6858000" cy="9144000"/>
@@ -882,7 +882,7 @@
           <p:cNvPr id="1" name="Title 1">
             <a:extLst xmlns:a="http://schemas.openxmlformats.org/drawingml/2006/main">
               <a:ext uri="{FF2B5EF4-FFF2-40B4-BE49-F238E27FC236}">
-                <a16:creationId xmlns:a16="http://schemas.microsoft.com/office/drawing/2014/main" id="{D976E638-9EDB-42F0-9D92-6D3942653B53}"/>
+                <a16:creationId xmlns:a16="http://schemas.microsoft.com/office/drawing/2014/main" id="{C3539627-7DDB-4A67-978D-2057E470FF38}"/>
               </a:ext>
             </a:extLst>
           </p:cNvPr>
@@ -913,7 +913,7 @@
           <p:cNvPr id="2" name="Subtitle 2">
             <a:extLst xmlns:a="http://schemas.openxmlformats.org/drawingml/2006/main">
               <a:ext uri="{FF2B5EF4-FFF2-40B4-BE49-F238E27FC236}">
-                <a16:creationId xmlns:a16="http://schemas.microsoft.com/office/drawing/2014/main" id="{04C2EBA8-28E7-4887-B062-8120448AD347}"/>
+                <a16:creationId xmlns:a16="http://schemas.microsoft.com/office/drawing/2014/main" id="{47CE4827-5EDC-4A67-B3AC-9E3E438F39FE}"/>
               </a:ext>
             </a:extLst>
           </p:cNvPr>
@@ -976,7 +976,7 @@
           <p:cNvPr id="3" name="Date Placeholder 3">
             <a:extLst xmlns:a="http://schemas.openxmlformats.org/drawingml/2006/main">
               <a:ext uri="{FF2B5EF4-FFF2-40B4-BE49-F238E27FC236}">
-                <a16:creationId xmlns:a16="http://schemas.microsoft.com/office/drawing/2014/main" id="{A4F41BD6-CCAC-4F52-AA49-867E6E554CBD}"/>
+                <a16:creationId xmlns:a16="http://schemas.microsoft.com/office/drawing/2014/main" id="{7585A02F-8562-4AA7-BD50-3C051484B9E9}"/>
               </a:ext>
             </a:extLst>
           </p:cNvPr>
@@ -997,7 +997,7 @@
           <p:cNvPr id="4" name="Footer Placeholder 4">
             <a:extLst xmlns:a="http://schemas.openxmlformats.org/drawingml/2006/main">
               <a:ext uri="{FF2B5EF4-FFF2-40B4-BE49-F238E27FC236}">
-                <a16:creationId xmlns:a16="http://schemas.microsoft.com/office/drawing/2014/main" id="{E8E3B97B-A007-4C96-8AAE-35DA3C77A06D}"/>
+                <a16:creationId xmlns:a16="http://schemas.microsoft.com/office/drawing/2014/main" id="{E57B9FFF-FBB8-4093-8AE7-8896BC896D2F}"/>
               </a:ext>
             </a:extLst>
           </p:cNvPr>
@@ -1018,7 +1018,7 @@
           <p:cNvPr id="5" name="Slide Number Placeholder 5">
             <a:extLst xmlns:a="http://schemas.openxmlformats.org/drawingml/2006/main">
               <a:ext uri="{FF2B5EF4-FFF2-40B4-BE49-F238E27FC236}">
-                <a16:creationId xmlns:a16="http://schemas.microsoft.com/office/drawing/2014/main" id="{77E5BACE-2531-45AD-B881-6DA5945DE19E}"/>
+                <a16:creationId xmlns:a16="http://schemas.microsoft.com/office/drawing/2014/main" id="{9E5C9098-3215-4B71-A866-2C5144D0CBAB}"/>
               </a:ext>
             </a:extLst>
           </p:cNvPr>
@@ -1061,7 +1061,7 @@
           <p:cNvPr id="1" name="Slide Number Placeholder 5">
             <a:extLst xmlns:a="http://schemas.openxmlformats.org/drawingml/2006/main">
               <a:ext uri="{FF2B5EF4-FFF2-40B4-BE49-F238E27FC236}">
-                <a16:creationId xmlns:a16="http://schemas.microsoft.com/office/drawing/2014/main" id="{6FFC4929-9468-4251-98CD-9F854FCB7E79}"/>
+                <a16:creationId xmlns:a16="http://schemas.microsoft.com/office/drawing/2014/main" id="{E9D2972E-58AB-4B8E-A6E2-8874F3CB3E3A}"/>
               </a:ext>
             </a:extLst>
           </p:cNvPr>
@@ -1100,7 +1100,7 @@
   </p:cSld>
   <p:clrMap bg1="lt1" tx1="dk1" bg2="lt2" tx2="dk2" accent1="accent1" accent2="accent2" accent3="accent3" accent4="accent4" accent5="accent5" accent6="accent6" hlink="hlink" folHlink="folHlink"/>
   <p:sldLayoutIdLst>
-    <p:sldLayoutId xmlns:r="http://schemas.openxmlformats.org/officeDocument/2006/relationships" id="2147483649" r:id="Rf45e3b7cbafe47ac"/>
+    <p:sldLayoutId xmlns:r="http://schemas.openxmlformats.org/officeDocument/2006/relationships" id="2147483649" r:id="Rfcc91bfee5234c78"/>
   </p:sldLayoutIdLst>
   <p:txStyles>
     <p:titleStyle>
@@ -1406,7 +1406,7 @@
           <p:cNvPr id="1" name="Slide Number Placeholder 5">
             <a:extLst xmlns:a="http://schemas.openxmlformats.org/drawingml/2006/main">
               <a:ext uri="{FF2B5EF4-FFF2-40B4-BE49-F238E27FC236}">
-                <a16:creationId xmlns:a16="http://schemas.microsoft.com/office/drawing/2014/main" id="{77E5BACE-2531-45AD-B881-6DA5945DE19E}"/>
+                <a16:creationId xmlns:a16="http://schemas.microsoft.com/office/drawing/2014/main" id="{9E5C9098-3215-4B71-A866-2C5144D0CBAB}"/>
               </a:ext>
             </a:extLst>
           </p:cNvPr>
@@ -1438,7 +1438,7 @@
           <p:cNvPr id="2" name="">
             <a:extLst xmlns:a="http://schemas.openxmlformats.org/drawingml/2006/main">
               <a:ext uri="{FF2B5EF4-FFF2-40B4-BE49-F238E27FC236}">
-                <a16:creationId xmlns:a16="http://schemas.microsoft.com/office/drawing/2014/main" id="{C0E82A56-1A1A-4923-9179-4CEE2DB28DC1}"/>
+                <a16:creationId xmlns:a16="http://schemas.microsoft.com/office/drawing/2014/main" id="{08699A6A-FA18-40E9-BC10-1DE5EC701B1A}"/>
               </a:ext>
             </a:extLst>
           </p:cNvPr>
@@ -1471,7 +1471,7 @@
           <p:cNvPr id="3" name="">
             <a:extLst xmlns:a="http://schemas.openxmlformats.org/drawingml/2006/main">
               <a:ext uri="{FF2B5EF4-FFF2-40B4-BE49-F238E27FC236}">
-                <a16:creationId xmlns:a16="http://schemas.microsoft.com/office/drawing/2014/main" id="{CC971A9C-D06B-41D7-82F1-481EFC95E75F}"/>
+                <a16:creationId xmlns:a16="http://schemas.microsoft.com/office/drawing/2014/main" id="{7D0B02C6-72F4-4F87-82A0-81169ECA7EBE}"/>
               </a:ext>
             </a:extLst>
           </p:cNvPr>
@@ -1504,7 +1504,7 @@
           <p:cNvPr id="4" name="">
             <a:extLst xmlns:a="http://schemas.openxmlformats.org/drawingml/2006/main">
               <a:ext uri="{FF2B5EF4-FFF2-40B4-BE49-F238E27FC236}">
-                <a16:creationId xmlns:a16="http://schemas.microsoft.com/office/drawing/2014/main" id="{E8BFA3F9-EA13-423C-8595-A830F9B6B1E5}"/>
+                <a16:creationId xmlns:a16="http://schemas.microsoft.com/office/drawing/2014/main" id="{09E8A248-F389-4E45-AD37-DEAD4C7F09C1}"/>
               </a:ext>
             </a:extLst>
           </p:cNvPr>
@@ -1564,7 +1564,7 @@
           <p:cNvPr id="5" name="">
             <a:extLst xmlns:a="http://schemas.openxmlformats.org/drawingml/2006/main">
               <a:ext uri="{FF2B5EF4-FFF2-40B4-BE49-F238E27FC236}">
-                <a16:creationId xmlns:a16="http://schemas.microsoft.com/office/drawing/2014/main" id="{A45EAA8F-D6BC-4788-AB2A-9071C29822FB}"/>
+                <a16:creationId xmlns:a16="http://schemas.microsoft.com/office/drawing/2014/main" id="{270D5B31-6AF6-421C-8DF7-F2DA281BCE19}"/>
               </a:ext>
             </a:extLst>
           </p:cNvPr>
@@ -1641,7 +1641,7 @@
           <p:cNvPr id="6" name="">
             <a:extLst xmlns:a="http://schemas.openxmlformats.org/drawingml/2006/main">
               <a:ext uri="{FF2B5EF4-FFF2-40B4-BE49-F238E27FC236}">
-                <a16:creationId xmlns:a16="http://schemas.microsoft.com/office/drawing/2014/main" id="{7A798536-FF26-4DD6-84A2-F1EA9A093C17}"/>
+                <a16:creationId xmlns:a16="http://schemas.microsoft.com/office/drawing/2014/main" id="{BB74B4C9-CBC1-4B96-8564-D9D913B085E3}"/>
               </a:ext>
             </a:extLst>
           </p:cNvPr>
@@ -1701,7 +1701,7 @@
           <p:cNvPr id="7" name="">
             <a:extLst xmlns:a="http://schemas.openxmlformats.org/drawingml/2006/main">
               <a:ext uri="{FF2B5EF4-FFF2-40B4-BE49-F238E27FC236}">
-                <a16:creationId xmlns:a16="http://schemas.microsoft.com/office/drawing/2014/main" id="{6087D593-8858-4333-BAF6-5DA99B9B3C74}"/>
+                <a16:creationId xmlns:a16="http://schemas.microsoft.com/office/drawing/2014/main" id="{3CAB106F-2DF3-481E-BCE4-F5E8583D167A}"/>
               </a:ext>
             </a:extLst>
           </p:cNvPr>
@@ -1736,7 +1736,7 @@
           <p:cNvPr id="8" name="">
             <a:extLst xmlns:a="http://schemas.openxmlformats.org/drawingml/2006/main">
               <a:ext uri="{FF2B5EF4-FFF2-40B4-BE49-F238E27FC236}">
-                <a16:creationId xmlns:a16="http://schemas.microsoft.com/office/drawing/2014/main" id="{4B9EE258-518B-4021-B989-C7BEEEEDF792}"/>
+                <a16:creationId xmlns:a16="http://schemas.microsoft.com/office/drawing/2014/main" id="{FD4D5D7C-2AAF-4BC8-BD94-C7D6D6D754EF}"/>
               </a:ext>
             </a:extLst>
           </p:cNvPr>
@@ -1769,7 +1769,7 @@
           <p:cNvPr id="9" name="">
             <a:extLst xmlns:a="http://schemas.openxmlformats.org/drawingml/2006/main">
               <a:ext uri="{FF2B5EF4-FFF2-40B4-BE49-F238E27FC236}">
-                <a16:creationId xmlns:a16="http://schemas.microsoft.com/office/drawing/2014/main" id="{63DB61BE-9A59-4003-95B9-6A31C39206F2}"/>
+                <a16:creationId xmlns:a16="http://schemas.microsoft.com/office/drawing/2014/main" id="{385B0C0E-BAF0-4196-93BD-E3A5A9F690A0}"/>
               </a:ext>
             </a:extLst>
           </p:cNvPr>
@@ -1829,7 +1829,7 @@
           <p:cNvPr id="10" name="">
             <a:extLst xmlns:a="http://schemas.openxmlformats.org/drawingml/2006/main">
               <a:ext uri="{FF2B5EF4-FFF2-40B4-BE49-F238E27FC236}">
-                <a16:creationId xmlns:a16="http://schemas.microsoft.com/office/drawing/2014/main" id="{582C39F6-6F7A-4411-B66E-5EAA0825A034}"/>
+                <a16:creationId xmlns:a16="http://schemas.microsoft.com/office/drawing/2014/main" id="{9A413155-CF43-4228-A556-AE2F81662070}"/>
               </a:ext>
             </a:extLst>
           </p:cNvPr>
@@ -1923,7 +1923,7 @@
           <p:cNvPr id="11" name="">
             <a:extLst xmlns:a="http://schemas.openxmlformats.org/drawingml/2006/main">
               <a:ext uri="{FF2B5EF4-FFF2-40B4-BE49-F238E27FC236}">
-                <a16:creationId xmlns:a16="http://schemas.microsoft.com/office/drawing/2014/main" id="{9A5DBB5C-39D8-47EB-BF13-066FBB6CBF45}"/>
+                <a16:creationId xmlns:a16="http://schemas.microsoft.com/office/drawing/2014/main" id="{7E778EF6-B188-4A63-8F9A-67B353A74484}"/>
               </a:ext>
             </a:extLst>
           </p:cNvPr>
@@ -1958,7 +1958,7 @@
           <p:cNvPr id="12" name="">
             <a:extLst xmlns:a="http://schemas.openxmlformats.org/drawingml/2006/main">
               <a:ext uri="{FF2B5EF4-FFF2-40B4-BE49-F238E27FC236}">
-                <a16:creationId xmlns:a16="http://schemas.microsoft.com/office/drawing/2014/main" id="{39B39698-4EB8-4A7D-8698-ED300D7A944C}"/>
+                <a16:creationId xmlns:a16="http://schemas.microsoft.com/office/drawing/2014/main" id="{59102FBA-101E-41CB-ADAB-2349CEF04784}"/>
               </a:ext>
             </a:extLst>
           </p:cNvPr>
@@ -1991,7 +1991,7 @@
           <p:cNvPr id="13" name="">
             <a:extLst xmlns:a="http://schemas.openxmlformats.org/drawingml/2006/main">
               <a:ext uri="{FF2B5EF4-FFF2-40B4-BE49-F238E27FC236}">
-                <a16:creationId xmlns:a16="http://schemas.microsoft.com/office/drawing/2014/main" id="{C55B5B5E-0590-4547-BAB2-6C42AA1C8ACA}"/>
+                <a16:creationId xmlns:a16="http://schemas.microsoft.com/office/drawing/2014/main" id="{22B863AC-459F-47CF-A6AF-F18BFE5B5440}"/>
               </a:ext>
             </a:extLst>
           </p:cNvPr>
@@ -2051,7 +2051,7 @@
           <p:cNvPr id="14" name="">
             <a:extLst xmlns:a="http://schemas.openxmlformats.org/drawingml/2006/main">
               <a:ext uri="{FF2B5EF4-FFF2-40B4-BE49-F238E27FC236}">
-                <a16:creationId xmlns:a16="http://schemas.microsoft.com/office/drawing/2014/main" id="{41E0FD21-7D31-4090-94F7-16C3E9B54BEB}"/>
+                <a16:creationId xmlns:a16="http://schemas.microsoft.com/office/drawing/2014/main" id="{5C2AA156-21E2-41DA-8001-AE6C1EF7A793}"/>
               </a:ext>
             </a:extLst>
           </p:cNvPr>
@@ -2111,19 +2111,19 @@
           <p:cNvPr id="15" name="">
             <a:extLst xmlns:a="http://schemas.openxmlformats.org/drawingml/2006/main">
               <a:ext uri="{FF2B5EF4-FFF2-40B4-BE49-F238E27FC236}">
-                <a16:creationId xmlns:a16="http://schemas.microsoft.com/office/drawing/2014/main" id="{C7F5E172-2C96-47E7-846D-FB80DB7CD3CA}"/>
-              </a:ext>
-            </a:extLst>
-          </p:cNvPr>
-          <p:cNvSpPr>
-            <a:spLocks xmlns:a="http://schemas.openxmlformats.org/drawingml/2006/main" noGrp="1"/>
-          </p:cNvSpPr>
-          <p:nvPr/>
-        </p:nvSpPr>
-        <p:spPr>
-          <a:xfrm xmlns:a="http://schemas.openxmlformats.org/drawingml/2006/main">
-            <a:off x="514350" y="6400800"/>
-            <a:ext cx="8572500" cy="171450"/>
+                <a16:creationId xmlns:a16="http://schemas.microsoft.com/office/drawing/2014/main" id="{66CBABAF-7454-4AE5-BA38-24B9554453B5}"/>
+              </a:ext>
+            </a:extLst>
+          </p:cNvPr>
+          <p:cNvSpPr>
+            <a:spLocks xmlns:a="http://schemas.openxmlformats.org/drawingml/2006/main" noGrp="1"/>
+          </p:cNvSpPr>
+          <p:nvPr/>
+        </p:nvSpPr>
+        <p:spPr>
+          <a:xfrm xmlns:a="http://schemas.openxmlformats.org/drawingml/2006/main">
+            <a:off x="514350" y="6381750"/>
+            <a:ext cx="8763000" cy="190500"/>
           </a:xfrm>
           <a:prstGeom xmlns:a="http://schemas.openxmlformats.org/drawingml/2006/main" prst="rect">
             <a:avLst/>
@@ -2149,14 +2149,14 @@
           <a:lstStyle xmlns:a="http://schemas.openxmlformats.org/drawingml/2006/main"/>
           <a:p xmlns:a="http://schemas.openxmlformats.org/drawingml/2006/main">
             <a:pPr algn="l">
-              <a:defRPr sz="713" b="0">
+              <a:defRPr sz="825" b="0">
                 <a:solidFill>
                   <a:srgbClr val="475569"/>
                 </a:solidFill>
               </a:defRPr>
             </a:pPr>
             <a:r>
-              <a:rPr sz="713" b="0">
+              <a:rPr sz="825" b="0">
                 <a:solidFill>
                   <a:srgbClr val="475569"/>
                 </a:solidFill>
@@ -2171,19 +2171,19 @@
           <p:cNvPr id="16" name="">
             <a:extLst xmlns:a="http://schemas.openxmlformats.org/drawingml/2006/main">
               <a:ext uri="{FF2B5EF4-FFF2-40B4-BE49-F238E27FC236}">
-                <a16:creationId xmlns:a16="http://schemas.microsoft.com/office/drawing/2014/main" id="{D20B5D6D-B932-4501-AAEF-BDB9F2DFE1BE}"/>
-              </a:ext>
-            </a:extLst>
-          </p:cNvPr>
-          <p:cNvSpPr>
-            <a:spLocks xmlns:a="http://schemas.openxmlformats.org/drawingml/2006/main" noGrp="1"/>
-          </p:cNvSpPr>
-          <p:nvPr/>
-        </p:nvSpPr>
-        <p:spPr>
-          <a:xfrm xmlns:a="http://schemas.openxmlformats.org/drawingml/2006/main">
-            <a:off x="11049000" y="6400800"/>
-            <a:ext cx="628650" cy="171450"/>
+                <a16:creationId xmlns:a16="http://schemas.microsoft.com/office/drawing/2014/main" id="{1E7FC5D7-656A-4BE9-8D62-05FA81D72920}"/>
+              </a:ext>
+            </a:extLst>
+          </p:cNvPr>
+          <p:cNvSpPr>
+            <a:spLocks xmlns:a="http://schemas.openxmlformats.org/drawingml/2006/main" noGrp="1"/>
+          </p:cNvSpPr>
+          <p:nvPr/>
+        </p:nvSpPr>
+        <p:spPr>
+          <a:xfrm xmlns:a="http://schemas.openxmlformats.org/drawingml/2006/main">
+            <a:off x="11049000" y="6381750"/>
+            <a:ext cx="628650" cy="190500"/>
           </a:xfrm>
           <a:prstGeom xmlns:a="http://schemas.openxmlformats.org/drawingml/2006/main" prst="rect">
             <a:avLst/>
@@ -2209,14 +2209,14 @@
           <a:lstStyle xmlns:a="http://schemas.openxmlformats.org/drawingml/2006/main"/>
           <a:p xmlns:a="http://schemas.openxmlformats.org/drawingml/2006/main">
             <a:pPr algn="r">
-              <a:defRPr sz="750" b="0">
+              <a:defRPr sz="825" b="0">
                 <a:solidFill>
                   <a:srgbClr val="475569"/>
                 </a:solidFill>
               </a:defRPr>
             </a:pPr>
             <a:r>
-              <a:rPr sz="750" b="0">
+              <a:rPr sz="825" b="0">
                 <a:solidFill>
                   <a:srgbClr val="475569"/>
                 </a:solidFill>
@@ -2229,7 +2229,7 @@
     </p:spTree>
     <p:extLst>
       <p:ext uri="{BB962C8B-B14F-4D97-AF65-F5344CB8AC3E}">
-        <p14:creationId xmlns:p14="http://schemas.microsoft.com/office/powerpoint/2010/main" val="926588908"/>
+        <p14:creationId xmlns:p14="http://schemas.microsoft.com/office/powerpoint/2010/main" val="1539782311"/>
       </p:ext>
     </p:extLst>
   </p:cSld>
@@ -2260,7 +2260,7 @@
           <p:cNvPr id="1" name="Slide Number Placeholder 5">
             <a:extLst xmlns:a="http://schemas.openxmlformats.org/drawingml/2006/main">
               <a:ext uri="{FF2B5EF4-FFF2-40B4-BE49-F238E27FC236}">
-                <a16:creationId xmlns:a16="http://schemas.microsoft.com/office/drawing/2014/main" id="{77E5BACE-2531-45AD-B881-6DA5945DE19E}"/>
+                <a16:creationId xmlns:a16="http://schemas.microsoft.com/office/drawing/2014/main" id="{9E5C9098-3215-4B71-A866-2C5144D0CBAB}"/>
               </a:ext>
             </a:extLst>
           </p:cNvPr>
@@ -2292,7 +2292,7 @@
           <p:cNvPr id="2" name="">
             <a:extLst xmlns:a="http://schemas.openxmlformats.org/drawingml/2006/main">
               <a:ext uri="{FF2B5EF4-FFF2-40B4-BE49-F238E27FC236}">
-                <a16:creationId xmlns:a16="http://schemas.microsoft.com/office/drawing/2014/main" id="{1BD619AA-0422-4E87-9DFE-FA9B5C38D971}"/>
+                <a16:creationId xmlns:a16="http://schemas.microsoft.com/office/drawing/2014/main" id="{84ED914A-51FE-4847-A492-436560F510CB}"/>
               </a:ext>
             </a:extLst>
           </p:cNvPr>
@@ -2352,7 +2352,7 @@
           <p:cNvPr id="3" name="">
             <a:extLst xmlns:a="http://schemas.openxmlformats.org/drawingml/2006/main">
               <a:ext uri="{FF2B5EF4-FFF2-40B4-BE49-F238E27FC236}">
-                <a16:creationId xmlns:a16="http://schemas.microsoft.com/office/drawing/2014/main" id="{B2C70407-40DD-42CF-80ED-447C63DDC6FA}"/>
+                <a16:creationId xmlns:a16="http://schemas.microsoft.com/office/drawing/2014/main" id="{0D89FF96-5D84-44AC-9494-8F9E446E60F9}"/>
               </a:ext>
             </a:extLst>
           </p:cNvPr>
@@ -2385,7 +2385,7 @@
           <p:cNvPr id="4" name="">
             <a:extLst xmlns:a="http://schemas.openxmlformats.org/drawingml/2006/main">
               <a:ext uri="{FF2B5EF4-FFF2-40B4-BE49-F238E27FC236}">
-                <a16:creationId xmlns:a16="http://schemas.microsoft.com/office/drawing/2014/main" id="{E13DD76F-B583-4160-BE69-21EB7CC14EED}"/>
+                <a16:creationId xmlns:a16="http://schemas.microsoft.com/office/drawing/2014/main" id="{36256DBA-A9B1-4B98-BDB1-EE92CCDCEE51}"/>
               </a:ext>
             </a:extLst>
           </p:cNvPr>
@@ -2462,7 +2462,7 @@
           <p:cNvPr id="5" name="">
             <a:extLst xmlns:a="http://schemas.openxmlformats.org/drawingml/2006/main">
               <a:ext uri="{FF2B5EF4-FFF2-40B4-BE49-F238E27FC236}">
-                <a16:creationId xmlns:a16="http://schemas.microsoft.com/office/drawing/2014/main" id="{C72CBFF2-3299-4860-BAAE-E4001AC1DB27}"/>
+                <a16:creationId xmlns:a16="http://schemas.microsoft.com/office/drawing/2014/main" id="{27CC2994-B669-4DC7-BB15-0018D0F28F54}"/>
               </a:ext>
             </a:extLst>
           </p:cNvPr>
@@ -2495,7 +2495,7 @@
           <p:cNvPr id="6" name="">
             <a:extLst xmlns:a="http://schemas.openxmlformats.org/drawingml/2006/main">
               <a:ext uri="{FF2B5EF4-FFF2-40B4-BE49-F238E27FC236}">
-                <a16:creationId xmlns:a16="http://schemas.microsoft.com/office/drawing/2014/main" id="{26AFDD34-BAE8-4FC6-A143-2135849B3B50}"/>
+                <a16:creationId xmlns:a16="http://schemas.microsoft.com/office/drawing/2014/main" id="{11BADA8C-BC6E-4736-A3BD-512B403E33F5}"/>
               </a:ext>
             </a:extLst>
           </p:cNvPr>
@@ -2572,7 +2572,7 @@
           <p:cNvPr id="7" name="">
             <a:extLst xmlns:a="http://schemas.openxmlformats.org/drawingml/2006/main">
               <a:ext uri="{FF2B5EF4-FFF2-40B4-BE49-F238E27FC236}">
-                <a16:creationId xmlns:a16="http://schemas.microsoft.com/office/drawing/2014/main" id="{B6AE7B3D-040E-4F68-89D8-1BC0ADF0DDE1}"/>
+                <a16:creationId xmlns:a16="http://schemas.microsoft.com/office/drawing/2014/main" id="{6EFA63E4-AE96-45E7-802E-790EF65FF06C}"/>
               </a:ext>
             </a:extLst>
           </p:cNvPr>
@@ -2649,7 +2649,7 @@
           <p:cNvPr id="8" name="">
             <a:extLst xmlns:a="http://schemas.openxmlformats.org/drawingml/2006/main">
               <a:ext uri="{FF2B5EF4-FFF2-40B4-BE49-F238E27FC236}">
-                <a16:creationId xmlns:a16="http://schemas.microsoft.com/office/drawing/2014/main" id="{95E84F62-C1D5-4BA9-80FC-90DC1DFF580F}"/>
+                <a16:creationId xmlns:a16="http://schemas.microsoft.com/office/drawing/2014/main" id="{A3A14C9C-DD38-43BA-921F-906D4551CFDC}"/>
               </a:ext>
             </a:extLst>
           </p:cNvPr>
@@ -2684,7 +2684,7 @@
           <p:cNvPr id="9" name="">
             <a:extLst xmlns:a="http://schemas.openxmlformats.org/drawingml/2006/main">
               <a:ext uri="{FF2B5EF4-FFF2-40B4-BE49-F238E27FC236}">
-                <a16:creationId xmlns:a16="http://schemas.microsoft.com/office/drawing/2014/main" id="{490BB9EA-3E09-4C9D-83C9-48E8427E3122}"/>
+                <a16:creationId xmlns:a16="http://schemas.microsoft.com/office/drawing/2014/main" id="{55CE60D0-F63E-4044-9224-28BE8F34A20C}"/>
               </a:ext>
             </a:extLst>
           </p:cNvPr>
@@ -2744,7 +2744,7 @@
           <p:cNvPr id="10" name="">
             <a:extLst xmlns:a="http://schemas.openxmlformats.org/drawingml/2006/main">
               <a:ext uri="{FF2B5EF4-FFF2-40B4-BE49-F238E27FC236}">
-                <a16:creationId xmlns:a16="http://schemas.microsoft.com/office/drawing/2014/main" id="{9D5C2059-AA53-4763-93CC-80DFCA3A9EC2}"/>
+                <a16:creationId xmlns:a16="http://schemas.microsoft.com/office/drawing/2014/main" id="{C38C9964-E8BF-4473-B200-999C2F040F67}"/>
               </a:ext>
             </a:extLst>
           </p:cNvPr>
@@ -2855,7 +2855,7 @@
           <p:cNvPr id="11" name="">
             <a:extLst xmlns:a="http://schemas.openxmlformats.org/drawingml/2006/main">
               <a:ext uri="{FF2B5EF4-FFF2-40B4-BE49-F238E27FC236}">
-                <a16:creationId xmlns:a16="http://schemas.microsoft.com/office/drawing/2014/main" id="{A7011C60-5843-4EEB-9D73-96ACAA7A55B6}"/>
+                <a16:creationId xmlns:a16="http://schemas.microsoft.com/office/drawing/2014/main" id="{0A414F26-46F2-4BC1-B7AF-F8C2AE314CE6}"/>
               </a:ext>
             </a:extLst>
           </p:cNvPr>
@@ -2915,7 +2915,7 @@
           <p:cNvPr id="12" name="">
             <a:extLst xmlns:a="http://schemas.openxmlformats.org/drawingml/2006/main">
               <a:ext uri="{FF2B5EF4-FFF2-40B4-BE49-F238E27FC236}">
-                <a16:creationId xmlns:a16="http://schemas.microsoft.com/office/drawing/2014/main" id="{0411F58C-D080-4E0E-9B92-94CCE82081DC}"/>
+                <a16:creationId xmlns:a16="http://schemas.microsoft.com/office/drawing/2014/main" id="{E2C0753C-0354-4406-A9C7-FAD61885E0DE}"/>
               </a:ext>
             </a:extLst>
           </p:cNvPr>
@@ -2950,19 +2950,19 @@
           <p:cNvPr id="13" name="">
             <a:extLst xmlns:a="http://schemas.openxmlformats.org/drawingml/2006/main">
               <a:ext uri="{FF2B5EF4-FFF2-40B4-BE49-F238E27FC236}">
-                <a16:creationId xmlns:a16="http://schemas.microsoft.com/office/drawing/2014/main" id="{471151B8-EE94-417D-A278-43AB752095FB}"/>
-              </a:ext>
-            </a:extLst>
-          </p:cNvPr>
-          <p:cNvSpPr>
-            <a:spLocks xmlns:a="http://schemas.openxmlformats.org/drawingml/2006/main" noGrp="1"/>
-          </p:cNvSpPr>
-          <p:nvPr/>
-        </p:nvSpPr>
-        <p:spPr>
-          <a:xfrm xmlns:a="http://schemas.openxmlformats.org/drawingml/2006/main">
-            <a:off x="9086850" y="4429125"/>
-            <a:ext cx="1104900" cy="123825"/>
+                <a16:creationId xmlns:a16="http://schemas.microsoft.com/office/drawing/2014/main" id="{EB7F7D5B-7013-4DF3-885D-55D12CDC68E2}"/>
+              </a:ext>
+            </a:extLst>
+          </p:cNvPr>
+          <p:cNvSpPr>
+            <a:spLocks xmlns:a="http://schemas.openxmlformats.org/drawingml/2006/main" noGrp="1"/>
+          </p:cNvSpPr>
+          <p:nvPr/>
+        </p:nvSpPr>
+        <p:spPr>
+          <a:xfrm xmlns:a="http://schemas.openxmlformats.org/drawingml/2006/main">
+            <a:off x="9086850" y="4419600"/>
+            <a:ext cx="1104900" cy="142875"/>
           </a:xfrm>
           <a:prstGeom xmlns:a="http://schemas.openxmlformats.org/drawingml/2006/main" prst="rect">
             <a:avLst/>
@@ -2988,14 +2988,14 @@
           <a:lstStyle xmlns:a="http://schemas.openxmlformats.org/drawingml/2006/main"/>
           <a:p xmlns:a="http://schemas.openxmlformats.org/drawingml/2006/main">
             <a:pPr algn="ctr">
-              <a:defRPr sz="638" b="1">
+              <a:defRPr sz="713" b="1">
                 <a:solidFill>
                   <a:srgbClr val="FFFFFF"/>
                 </a:solidFill>
               </a:defRPr>
             </a:pPr>
             <a:r>
-              <a:rPr sz="638" b="1">
+              <a:rPr sz="713" b="1">
                 <a:solidFill>
                   <a:srgbClr val="FFFFFF"/>
                 </a:solidFill>
@@ -3010,19 +3010,19 @@
           <p:cNvPr id="14" name="">
             <a:extLst xmlns:a="http://schemas.openxmlformats.org/drawingml/2006/main">
               <a:ext uri="{FF2B5EF4-FFF2-40B4-BE49-F238E27FC236}">
-                <a16:creationId xmlns:a16="http://schemas.microsoft.com/office/drawing/2014/main" id="{F1207678-985B-4A17-AAE3-C3F558EE3BFE}"/>
-              </a:ext>
-            </a:extLst>
-          </p:cNvPr>
-          <p:cNvSpPr>
-            <a:spLocks xmlns:a="http://schemas.openxmlformats.org/drawingml/2006/main" noGrp="1"/>
-          </p:cNvSpPr>
-          <p:nvPr/>
-        </p:nvSpPr>
-        <p:spPr>
-          <a:xfrm xmlns:a="http://schemas.openxmlformats.org/drawingml/2006/main">
-            <a:off x="514350" y="6400800"/>
-            <a:ext cx="8572500" cy="171450"/>
+                <a16:creationId xmlns:a16="http://schemas.microsoft.com/office/drawing/2014/main" id="{37A5CD1C-8605-4C08-97C9-ECF83F90AC16}"/>
+              </a:ext>
+            </a:extLst>
+          </p:cNvPr>
+          <p:cNvSpPr>
+            <a:spLocks xmlns:a="http://schemas.openxmlformats.org/drawingml/2006/main" noGrp="1"/>
+          </p:cNvSpPr>
+          <p:nvPr/>
+        </p:nvSpPr>
+        <p:spPr>
+          <a:xfrm xmlns:a="http://schemas.openxmlformats.org/drawingml/2006/main">
+            <a:off x="514350" y="6381750"/>
+            <a:ext cx="8763000" cy="190500"/>
           </a:xfrm>
           <a:prstGeom xmlns:a="http://schemas.openxmlformats.org/drawingml/2006/main" prst="rect">
             <a:avLst/>
@@ -3048,14 +3048,14 @@
           <a:lstStyle xmlns:a="http://schemas.openxmlformats.org/drawingml/2006/main"/>
           <a:p xmlns:a="http://schemas.openxmlformats.org/drawingml/2006/main">
             <a:pPr algn="l">
-              <a:defRPr sz="713" b="0">
+              <a:defRPr sz="825" b="0">
                 <a:solidFill>
                   <a:srgbClr val="475569"/>
                 </a:solidFill>
               </a:defRPr>
             </a:pPr>
             <a:r>
-              <a:rPr sz="713" b="0">
+              <a:rPr sz="825" b="0">
                 <a:solidFill>
                   <a:srgbClr val="475569"/>
                 </a:solidFill>
@@ -3070,19 +3070,19 @@
           <p:cNvPr id="15" name="">
             <a:extLst xmlns:a="http://schemas.openxmlformats.org/drawingml/2006/main">
               <a:ext uri="{FF2B5EF4-FFF2-40B4-BE49-F238E27FC236}">
-                <a16:creationId xmlns:a16="http://schemas.microsoft.com/office/drawing/2014/main" id="{AA5B516D-665A-478C-BAE9-BD04C870F8CF}"/>
-              </a:ext>
-            </a:extLst>
-          </p:cNvPr>
-          <p:cNvSpPr>
-            <a:spLocks xmlns:a="http://schemas.openxmlformats.org/drawingml/2006/main" noGrp="1"/>
-          </p:cNvSpPr>
-          <p:nvPr/>
-        </p:nvSpPr>
-        <p:spPr>
-          <a:xfrm xmlns:a="http://schemas.openxmlformats.org/drawingml/2006/main">
-            <a:off x="11049000" y="6400800"/>
-            <a:ext cx="628650" cy="171450"/>
+                <a16:creationId xmlns:a16="http://schemas.microsoft.com/office/drawing/2014/main" id="{F4D8F276-723C-408F-BD9D-041B1E32BA86}"/>
+              </a:ext>
+            </a:extLst>
+          </p:cNvPr>
+          <p:cNvSpPr>
+            <a:spLocks xmlns:a="http://schemas.openxmlformats.org/drawingml/2006/main" noGrp="1"/>
+          </p:cNvSpPr>
+          <p:nvPr/>
+        </p:nvSpPr>
+        <p:spPr>
+          <a:xfrm xmlns:a="http://schemas.openxmlformats.org/drawingml/2006/main">
+            <a:off x="11049000" y="6381750"/>
+            <a:ext cx="628650" cy="190500"/>
           </a:xfrm>
           <a:prstGeom xmlns:a="http://schemas.openxmlformats.org/drawingml/2006/main" prst="rect">
             <a:avLst/>
@@ -3108,14 +3108,14 @@
           <a:lstStyle xmlns:a="http://schemas.openxmlformats.org/drawingml/2006/main"/>
           <a:p xmlns:a="http://schemas.openxmlformats.org/drawingml/2006/main">
             <a:pPr algn="r">
-              <a:defRPr sz="750" b="0">
+              <a:defRPr sz="825" b="0">
                 <a:solidFill>
                   <a:srgbClr val="475569"/>
                 </a:solidFill>
               </a:defRPr>
             </a:pPr>
             <a:r>
-              <a:rPr sz="750" b="0">
+              <a:rPr sz="825" b="0">
                 <a:solidFill>
                   <a:srgbClr val="475569"/>
                 </a:solidFill>
@@ -3128,7 +3128,7 @@
     </p:spTree>
     <p:extLst>
       <p:ext uri="{BB962C8B-B14F-4D97-AF65-F5344CB8AC3E}">
-        <p14:creationId xmlns:p14="http://schemas.microsoft.com/office/powerpoint/2010/main" val="1821309798"/>
+        <p14:creationId xmlns:p14="http://schemas.microsoft.com/office/powerpoint/2010/main" val="104590581"/>
       </p:ext>
     </p:extLst>
   </p:cSld>
@@ -3159,7 +3159,7 @@
           <p:cNvPr id="1" name="Slide Number Placeholder 5">
             <a:extLst xmlns:a="http://schemas.openxmlformats.org/drawingml/2006/main">
               <a:ext uri="{FF2B5EF4-FFF2-40B4-BE49-F238E27FC236}">
-                <a16:creationId xmlns:a16="http://schemas.microsoft.com/office/drawing/2014/main" id="{77E5BACE-2531-45AD-B881-6DA5945DE19E}"/>
+                <a16:creationId xmlns:a16="http://schemas.microsoft.com/office/drawing/2014/main" id="{9E5C9098-3215-4B71-A866-2C5144D0CBAB}"/>
               </a:ext>
             </a:extLst>
           </p:cNvPr>
@@ -3191,7 +3191,7 @@
           <p:cNvPr id="2" name="">
             <a:extLst xmlns:a="http://schemas.openxmlformats.org/drawingml/2006/main">
               <a:ext uri="{FF2B5EF4-FFF2-40B4-BE49-F238E27FC236}">
-                <a16:creationId xmlns:a16="http://schemas.microsoft.com/office/drawing/2014/main" id="{1BA882AB-9C99-481F-A783-E2C390F71700}"/>
+                <a16:creationId xmlns:a16="http://schemas.microsoft.com/office/drawing/2014/main" id="{1C12BDC0-2D9F-43DE-AB46-7B02D978EC26}"/>
               </a:ext>
             </a:extLst>
           </p:cNvPr>
@@ -3224,7 +3224,7 @@
           <p:cNvPr id="3" name="">
             <a:extLst xmlns:a="http://schemas.openxmlformats.org/drawingml/2006/main">
               <a:ext uri="{FF2B5EF4-FFF2-40B4-BE49-F238E27FC236}">
-                <a16:creationId xmlns:a16="http://schemas.microsoft.com/office/drawing/2014/main" id="{82CA6CF0-3D0C-4A2C-B2B6-B320DE0E59C9}"/>
+                <a16:creationId xmlns:a16="http://schemas.microsoft.com/office/drawing/2014/main" id="{D6CD0A74-F3CC-4E9B-A423-78A61E05A549}"/>
               </a:ext>
             </a:extLst>
           </p:cNvPr>
@@ -3257,7 +3257,7 @@
           <p:cNvPr id="4" name="">
             <a:extLst xmlns:a="http://schemas.openxmlformats.org/drawingml/2006/main">
               <a:ext uri="{FF2B5EF4-FFF2-40B4-BE49-F238E27FC236}">
-                <a16:creationId xmlns:a16="http://schemas.microsoft.com/office/drawing/2014/main" id="{FB0C05EA-1911-44D2-962E-1E6B57996B3A}"/>
+                <a16:creationId xmlns:a16="http://schemas.microsoft.com/office/drawing/2014/main" id="{6226898E-9913-47B7-B85C-D219C2BBA384}"/>
               </a:ext>
             </a:extLst>
           </p:cNvPr>
@@ -3317,7 +3317,7 @@
           <p:cNvPr id="5" name="">
             <a:extLst xmlns:a="http://schemas.openxmlformats.org/drawingml/2006/main">
               <a:ext uri="{FF2B5EF4-FFF2-40B4-BE49-F238E27FC236}">
-                <a16:creationId xmlns:a16="http://schemas.microsoft.com/office/drawing/2014/main" id="{13BD0F42-3A67-4CD7-985E-4B7AD6647729}"/>
+                <a16:creationId xmlns:a16="http://schemas.microsoft.com/office/drawing/2014/main" id="{AB2F68FD-B2AD-414D-B445-4204717531D3}"/>
               </a:ext>
             </a:extLst>
           </p:cNvPr>
@@ -3377,7 +3377,7 @@
           <p:cNvPr id="6" name="">
             <a:extLst xmlns:a="http://schemas.openxmlformats.org/drawingml/2006/main">
               <a:ext uri="{FF2B5EF4-FFF2-40B4-BE49-F238E27FC236}">
-                <a16:creationId xmlns:a16="http://schemas.microsoft.com/office/drawing/2014/main" id="{50F02B8B-A9F8-4385-B5AF-3AD7D656131F}"/>
+                <a16:creationId xmlns:a16="http://schemas.microsoft.com/office/drawing/2014/main" id="{E56878A0-1BEC-4E58-AAAE-5833B3ABB401}"/>
               </a:ext>
             </a:extLst>
           </p:cNvPr>
@@ -3437,7 +3437,7 @@
           <p:cNvPr id="7" name="">
             <a:extLst xmlns:a="http://schemas.openxmlformats.org/drawingml/2006/main">
               <a:ext uri="{FF2B5EF4-FFF2-40B4-BE49-F238E27FC236}">
-                <a16:creationId xmlns:a16="http://schemas.microsoft.com/office/drawing/2014/main" id="{41322288-5CD1-47B4-9C01-80D250CB4C89}"/>
+                <a16:creationId xmlns:a16="http://schemas.microsoft.com/office/drawing/2014/main" id="{F6592882-A1DC-426C-B567-528DE902EA9A}"/>
               </a:ext>
             </a:extLst>
           </p:cNvPr>
@@ -3497,7 +3497,7 @@
           <p:cNvPr id="8" name="">
             <a:extLst xmlns:a="http://schemas.openxmlformats.org/drawingml/2006/main">
               <a:ext uri="{FF2B5EF4-FFF2-40B4-BE49-F238E27FC236}">
-                <a16:creationId xmlns:a16="http://schemas.microsoft.com/office/drawing/2014/main" id="{9905ED70-2C28-429E-A170-33A6E7F02E2A}"/>
+                <a16:creationId xmlns:a16="http://schemas.microsoft.com/office/drawing/2014/main" id="{FF8BD617-FD26-4685-9840-E262CB5914D9}"/>
               </a:ext>
             </a:extLst>
           </p:cNvPr>
@@ -3557,7 +3557,7 @@
           <p:cNvPr id="9" name="">
             <a:extLst xmlns:a="http://schemas.openxmlformats.org/drawingml/2006/main">
               <a:ext uri="{FF2B5EF4-FFF2-40B4-BE49-F238E27FC236}">
-                <a16:creationId xmlns:a16="http://schemas.microsoft.com/office/drawing/2014/main" id="{1F32A035-8771-4BD6-AB48-1CD4537D2E4A}"/>
+                <a16:creationId xmlns:a16="http://schemas.microsoft.com/office/drawing/2014/main" id="{B088B4F4-C5F1-4688-8321-9593F6DBA0C2}"/>
               </a:ext>
             </a:extLst>
           </p:cNvPr>
@@ -3617,7 +3617,7 @@
           <p:cNvPr id="10" name="">
             <a:extLst xmlns:a="http://schemas.openxmlformats.org/drawingml/2006/main">
               <a:ext uri="{FF2B5EF4-FFF2-40B4-BE49-F238E27FC236}">
-                <a16:creationId xmlns:a16="http://schemas.microsoft.com/office/drawing/2014/main" id="{1A408057-51BA-4423-BC4C-6337DCC89FF2}"/>
+                <a16:creationId xmlns:a16="http://schemas.microsoft.com/office/drawing/2014/main" id="{F12ECCEB-B0E6-4BA4-847B-48A5DD74205E}"/>
               </a:ext>
             </a:extLst>
           </p:cNvPr>
@@ -3677,7 +3677,7 @@
           <p:cNvPr id="11" name="">
             <a:extLst xmlns:a="http://schemas.openxmlformats.org/drawingml/2006/main">
               <a:ext uri="{FF2B5EF4-FFF2-40B4-BE49-F238E27FC236}">
-                <a16:creationId xmlns:a16="http://schemas.microsoft.com/office/drawing/2014/main" id="{E766115F-B398-41F0-B021-FD9FB9BFF257}"/>
+                <a16:creationId xmlns:a16="http://schemas.microsoft.com/office/drawing/2014/main" id="{57673D05-6697-430E-B9B0-5C5C3E3000F3}"/>
               </a:ext>
             </a:extLst>
           </p:cNvPr>
@@ -3712,7 +3712,7 @@
           <p:cNvPr id="12" name="">
             <a:extLst xmlns:a="http://schemas.openxmlformats.org/drawingml/2006/main">
               <a:ext uri="{FF2B5EF4-FFF2-40B4-BE49-F238E27FC236}">
-                <a16:creationId xmlns:a16="http://schemas.microsoft.com/office/drawing/2014/main" id="{C54E2DEB-102E-42E0-813E-C49302F98173}"/>
+                <a16:creationId xmlns:a16="http://schemas.microsoft.com/office/drawing/2014/main" id="{56572480-26C9-4C27-BB78-AAA45A9F65BC}"/>
               </a:ext>
             </a:extLst>
           </p:cNvPr>
@@ -3789,7 +3789,7 @@
           <p:cNvPr id="13" name="">
             <a:extLst xmlns:a="http://schemas.openxmlformats.org/drawingml/2006/main">
               <a:ext uri="{FF2B5EF4-FFF2-40B4-BE49-F238E27FC236}">
-                <a16:creationId xmlns:a16="http://schemas.microsoft.com/office/drawing/2014/main" id="{AEB5A085-A0FB-4DC2-B002-EFF47EAD45F6}"/>
+                <a16:creationId xmlns:a16="http://schemas.microsoft.com/office/drawing/2014/main" id="{93606CA5-7EFE-443A-92AA-97016B74BB75}"/>
               </a:ext>
             </a:extLst>
           </p:cNvPr>
@@ -3824,7 +3824,7 @@
           <p:cNvPr id="14" name="">
             <a:extLst xmlns:a="http://schemas.openxmlformats.org/drawingml/2006/main">
               <a:ext uri="{FF2B5EF4-FFF2-40B4-BE49-F238E27FC236}">
-                <a16:creationId xmlns:a16="http://schemas.microsoft.com/office/drawing/2014/main" id="{CE26A93D-84BA-49A1-B752-66B6E7546329}"/>
+                <a16:creationId xmlns:a16="http://schemas.microsoft.com/office/drawing/2014/main" id="{7CD9BAA7-83C7-436B-A026-73232FD87D40}"/>
               </a:ext>
             </a:extLst>
           </p:cNvPr>
@@ -3884,7 +3884,7 @@
           <p:cNvPr id="15" name="">
             <a:extLst xmlns:a="http://schemas.openxmlformats.org/drawingml/2006/main">
               <a:ext uri="{FF2B5EF4-FFF2-40B4-BE49-F238E27FC236}">
-                <a16:creationId xmlns:a16="http://schemas.microsoft.com/office/drawing/2014/main" id="{E9675BE4-135D-456B-BE92-A6B63409A156}"/>
+                <a16:creationId xmlns:a16="http://schemas.microsoft.com/office/drawing/2014/main" id="{1093BCE1-9AFC-4BBB-81E2-54EC6ED31E5E}"/>
               </a:ext>
             </a:extLst>
           </p:cNvPr>
@@ -3944,7 +3944,7 @@
           <p:cNvPr id="16" name="">
             <a:extLst xmlns:a="http://schemas.openxmlformats.org/drawingml/2006/main">
               <a:ext uri="{FF2B5EF4-FFF2-40B4-BE49-F238E27FC236}">
-                <a16:creationId xmlns:a16="http://schemas.microsoft.com/office/drawing/2014/main" id="{067B9507-CF66-4D75-A700-7C8C3D87085F}"/>
+                <a16:creationId xmlns:a16="http://schemas.microsoft.com/office/drawing/2014/main" id="{14662335-D5BF-4F7F-B35C-50DF6C142E87}"/>
               </a:ext>
             </a:extLst>
           </p:cNvPr>
@@ -3979,7 +3979,7 @@
           <p:cNvPr id="17" name="">
             <a:extLst xmlns:a="http://schemas.openxmlformats.org/drawingml/2006/main">
               <a:ext uri="{FF2B5EF4-FFF2-40B4-BE49-F238E27FC236}">
-                <a16:creationId xmlns:a16="http://schemas.microsoft.com/office/drawing/2014/main" id="{7C250AAD-E9A0-4813-BAFA-369AFCE49ADE}"/>
+                <a16:creationId xmlns:a16="http://schemas.microsoft.com/office/drawing/2014/main" id="{803E0681-8900-4EFC-B6AA-65BBBA052D3F}"/>
               </a:ext>
             </a:extLst>
           </p:cNvPr>
@@ -4039,7 +4039,7 @@
           <p:cNvPr id="18" name="">
             <a:extLst xmlns:a="http://schemas.openxmlformats.org/drawingml/2006/main">
               <a:ext uri="{FF2B5EF4-FFF2-40B4-BE49-F238E27FC236}">
-                <a16:creationId xmlns:a16="http://schemas.microsoft.com/office/drawing/2014/main" id="{31587C87-5A0E-4A10-BE1B-828C2CF7B288}"/>
+                <a16:creationId xmlns:a16="http://schemas.microsoft.com/office/drawing/2014/main" id="{3A919D29-7BD2-499F-89AE-946C0362F0B3}"/>
               </a:ext>
             </a:extLst>
           </p:cNvPr>
@@ -4074,7 +4074,7 @@
           <p:cNvPr id="19" name="">
             <a:extLst xmlns:a="http://schemas.openxmlformats.org/drawingml/2006/main">
               <a:ext uri="{FF2B5EF4-FFF2-40B4-BE49-F238E27FC236}">
-                <a16:creationId xmlns:a16="http://schemas.microsoft.com/office/drawing/2014/main" id="{D99A6D54-C6AD-4A04-BEF1-71D230A61973}"/>
+                <a16:creationId xmlns:a16="http://schemas.microsoft.com/office/drawing/2014/main" id="{E3F41BA7-1A53-436F-968E-45CC40EC341B}"/>
               </a:ext>
             </a:extLst>
           </p:cNvPr>
@@ -4151,7 +4151,7 @@
           <p:cNvPr id="20" name="">
             <a:extLst xmlns:a="http://schemas.openxmlformats.org/drawingml/2006/main">
               <a:ext uri="{FF2B5EF4-FFF2-40B4-BE49-F238E27FC236}">
-                <a16:creationId xmlns:a16="http://schemas.microsoft.com/office/drawing/2014/main" id="{28197CE7-83DF-461A-B8BE-B213CFFC70EB}"/>
+                <a16:creationId xmlns:a16="http://schemas.microsoft.com/office/drawing/2014/main" id="{70E76FD3-9464-4976-AD3B-A110AB7EFC52}"/>
               </a:ext>
             </a:extLst>
           </p:cNvPr>
@@ -4211,7 +4211,7 @@
           <p:cNvPr id="21" name="">
             <a:extLst xmlns:a="http://schemas.openxmlformats.org/drawingml/2006/main">
               <a:ext uri="{FF2B5EF4-FFF2-40B4-BE49-F238E27FC236}">
-                <a16:creationId xmlns:a16="http://schemas.microsoft.com/office/drawing/2014/main" id="{C58EC160-D75F-4B02-87F7-478C0E53DE9A}"/>
+                <a16:creationId xmlns:a16="http://schemas.microsoft.com/office/drawing/2014/main" id="{051CA8CE-9C35-4425-8EB4-C279D404DB97}"/>
               </a:ext>
             </a:extLst>
           </p:cNvPr>
@@ -4246,7 +4246,7 @@
           <p:cNvPr id="22" name="">
             <a:extLst xmlns:a="http://schemas.openxmlformats.org/drawingml/2006/main">
               <a:ext uri="{FF2B5EF4-FFF2-40B4-BE49-F238E27FC236}">
-                <a16:creationId xmlns:a16="http://schemas.microsoft.com/office/drawing/2014/main" id="{018ABC36-9BC2-488C-9EC3-C8C3A73F0267}"/>
+                <a16:creationId xmlns:a16="http://schemas.microsoft.com/office/drawing/2014/main" id="{450CF5EE-8D24-4026-A97D-BFE227414DDF}"/>
               </a:ext>
             </a:extLst>
           </p:cNvPr>
@@ -4306,7 +4306,7 @@
           <p:cNvPr id="23" name="">
             <a:extLst xmlns:a="http://schemas.openxmlformats.org/drawingml/2006/main">
               <a:ext uri="{FF2B5EF4-FFF2-40B4-BE49-F238E27FC236}">
-                <a16:creationId xmlns:a16="http://schemas.microsoft.com/office/drawing/2014/main" id="{6B9AE109-8D52-4614-A31E-2FC28E90E130}"/>
+                <a16:creationId xmlns:a16="http://schemas.microsoft.com/office/drawing/2014/main" id="{F5AFC1C1-8871-4DC3-808B-BF3D0841ADEB}"/>
               </a:ext>
             </a:extLst>
           </p:cNvPr>
@@ -4341,7 +4341,7 @@
           <p:cNvPr id="24" name="">
             <a:extLst xmlns:a="http://schemas.openxmlformats.org/drawingml/2006/main">
               <a:ext uri="{FF2B5EF4-FFF2-40B4-BE49-F238E27FC236}">
-                <a16:creationId xmlns:a16="http://schemas.microsoft.com/office/drawing/2014/main" id="{BF2EA77C-613C-404A-B3EA-043185FD49E7}"/>
+                <a16:creationId xmlns:a16="http://schemas.microsoft.com/office/drawing/2014/main" id="{2F003D7D-EE33-459B-BD61-6DF31B63950B}"/>
               </a:ext>
             </a:extLst>
           </p:cNvPr>
@@ -4418,7 +4418,7 @@
           <p:cNvPr id="25" name="">
             <a:extLst xmlns:a="http://schemas.openxmlformats.org/drawingml/2006/main">
               <a:ext uri="{FF2B5EF4-FFF2-40B4-BE49-F238E27FC236}">
-                <a16:creationId xmlns:a16="http://schemas.microsoft.com/office/drawing/2014/main" id="{627367BD-9FFD-4593-B67C-E0E7BD75DEC6}"/>
+                <a16:creationId xmlns:a16="http://schemas.microsoft.com/office/drawing/2014/main" id="{8ED113DC-7C59-4ACD-B1AD-0A760B83B1B4}"/>
               </a:ext>
             </a:extLst>
           </p:cNvPr>
@@ -4453,7 +4453,7 @@
           <p:cNvPr id="26" name="">
             <a:extLst xmlns:a="http://schemas.openxmlformats.org/drawingml/2006/main">
               <a:ext uri="{FF2B5EF4-FFF2-40B4-BE49-F238E27FC236}">
-                <a16:creationId xmlns:a16="http://schemas.microsoft.com/office/drawing/2014/main" id="{8405EC51-290B-46FA-B583-388AF6FAF854}"/>
+                <a16:creationId xmlns:a16="http://schemas.microsoft.com/office/drawing/2014/main" id="{E87A28E7-A780-4A7B-AB6F-DF4153CB12B8}"/>
               </a:ext>
             </a:extLst>
           </p:cNvPr>
@@ -4486,7 +4486,7 @@
           <p:cNvPr id="27" name="">
             <a:extLst xmlns:a="http://schemas.openxmlformats.org/drawingml/2006/main">
               <a:ext uri="{FF2B5EF4-FFF2-40B4-BE49-F238E27FC236}">
-                <a16:creationId xmlns:a16="http://schemas.microsoft.com/office/drawing/2014/main" id="{D018F23B-13F7-4C02-846B-9AD49DAD7364}"/>
+                <a16:creationId xmlns:a16="http://schemas.microsoft.com/office/drawing/2014/main" id="{4870FFB2-AD76-4E19-904D-886F039BBDA2}"/>
               </a:ext>
             </a:extLst>
           </p:cNvPr>
@@ -4546,7 +4546,7 @@
           <p:cNvPr id="28" name="">
             <a:extLst xmlns:a="http://schemas.openxmlformats.org/drawingml/2006/main">
               <a:ext uri="{FF2B5EF4-FFF2-40B4-BE49-F238E27FC236}">
-                <a16:creationId xmlns:a16="http://schemas.microsoft.com/office/drawing/2014/main" id="{59128C5A-3B97-4A6B-A34C-F3C9DBD13928}"/>
+                <a16:creationId xmlns:a16="http://schemas.microsoft.com/office/drawing/2014/main" id="{43F21497-DFC0-4CB3-AC3C-59A0C8224966}"/>
               </a:ext>
             </a:extLst>
           </p:cNvPr>
@@ -4623,19 +4623,19 @@
           <p:cNvPr id="29" name="">
             <a:extLst xmlns:a="http://schemas.openxmlformats.org/drawingml/2006/main">
               <a:ext uri="{FF2B5EF4-FFF2-40B4-BE49-F238E27FC236}">
-                <a16:creationId xmlns:a16="http://schemas.microsoft.com/office/drawing/2014/main" id="{153A6179-C618-489E-8C39-ED29694E9DF8}"/>
-              </a:ext>
-            </a:extLst>
-          </p:cNvPr>
-          <p:cNvSpPr>
-            <a:spLocks xmlns:a="http://schemas.openxmlformats.org/drawingml/2006/main" noGrp="1"/>
-          </p:cNvSpPr>
-          <p:nvPr/>
-        </p:nvSpPr>
-        <p:spPr>
-          <a:xfrm xmlns:a="http://schemas.openxmlformats.org/drawingml/2006/main">
-            <a:off x="514350" y="6400800"/>
-            <a:ext cx="8572500" cy="171450"/>
+                <a16:creationId xmlns:a16="http://schemas.microsoft.com/office/drawing/2014/main" id="{E42BE1AB-AD1F-447F-8071-6B825CE27B9A}"/>
+              </a:ext>
+            </a:extLst>
+          </p:cNvPr>
+          <p:cNvSpPr>
+            <a:spLocks xmlns:a="http://schemas.openxmlformats.org/drawingml/2006/main" noGrp="1"/>
+          </p:cNvSpPr>
+          <p:nvPr/>
+        </p:nvSpPr>
+        <p:spPr>
+          <a:xfrm xmlns:a="http://schemas.openxmlformats.org/drawingml/2006/main">
+            <a:off x="514350" y="6381750"/>
+            <a:ext cx="8763000" cy="190500"/>
           </a:xfrm>
           <a:prstGeom xmlns:a="http://schemas.openxmlformats.org/drawingml/2006/main" prst="rect">
             <a:avLst/>
@@ -4661,14 +4661,14 @@
           <a:lstStyle xmlns:a="http://schemas.openxmlformats.org/drawingml/2006/main"/>
           <a:p xmlns:a="http://schemas.openxmlformats.org/drawingml/2006/main">
             <a:pPr algn="l">
-              <a:defRPr sz="713" b="0">
+              <a:defRPr sz="825" b="0">
                 <a:solidFill>
                   <a:srgbClr val="475569"/>
                 </a:solidFill>
               </a:defRPr>
             </a:pPr>
             <a:r>
-              <a:rPr sz="713" b="0">
+              <a:rPr sz="825" b="0">
                 <a:solidFill>
                   <a:srgbClr val="475569"/>
                 </a:solidFill>
@@ -4683,19 +4683,19 @@
           <p:cNvPr id="30" name="">
             <a:extLst xmlns:a="http://schemas.openxmlformats.org/drawingml/2006/main">
               <a:ext uri="{FF2B5EF4-FFF2-40B4-BE49-F238E27FC236}">
-                <a16:creationId xmlns:a16="http://schemas.microsoft.com/office/drawing/2014/main" id="{BC8B5044-8206-49A6-81E2-CD9EBD8E74A4}"/>
-              </a:ext>
-            </a:extLst>
-          </p:cNvPr>
-          <p:cNvSpPr>
-            <a:spLocks xmlns:a="http://schemas.openxmlformats.org/drawingml/2006/main" noGrp="1"/>
-          </p:cNvSpPr>
-          <p:nvPr/>
-        </p:nvSpPr>
-        <p:spPr>
-          <a:xfrm xmlns:a="http://schemas.openxmlformats.org/drawingml/2006/main">
-            <a:off x="11049000" y="6400800"/>
-            <a:ext cx="628650" cy="171450"/>
+                <a16:creationId xmlns:a16="http://schemas.microsoft.com/office/drawing/2014/main" id="{9EE15CC5-274C-4A52-88D8-AA88620496E4}"/>
+              </a:ext>
+            </a:extLst>
+          </p:cNvPr>
+          <p:cNvSpPr>
+            <a:spLocks xmlns:a="http://schemas.openxmlformats.org/drawingml/2006/main" noGrp="1"/>
+          </p:cNvSpPr>
+          <p:nvPr/>
+        </p:nvSpPr>
+        <p:spPr>
+          <a:xfrm xmlns:a="http://schemas.openxmlformats.org/drawingml/2006/main">
+            <a:off x="11049000" y="6381750"/>
+            <a:ext cx="628650" cy="190500"/>
           </a:xfrm>
           <a:prstGeom xmlns:a="http://schemas.openxmlformats.org/drawingml/2006/main" prst="rect">
             <a:avLst/>
@@ -4721,14 +4721,14 @@
           <a:lstStyle xmlns:a="http://schemas.openxmlformats.org/drawingml/2006/main"/>
           <a:p xmlns:a="http://schemas.openxmlformats.org/drawingml/2006/main">
             <a:pPr algn="r">
-              <a:defRPr sz="750" b="0">
+              <a:defRPr sz="825" b="0">
                 <a:solidFill>
                   <a:srgbClr val="475569"/>
                 </a:solidFill>
               </a:defRPr>
             </a:pPr>
             <a:r>
-              <a:rPr sz="750" b="0">
+              <a:rPr sz="825" b="0">
                 <a:solidFill>
                   <a:srgbClr val="475569"/>
                 </a:solidFill>
@@ -4741,7 +4741,7 @@
     </p:spTree>
     <p:extLst>
       <p:ext uri="{BB962C8B-B14F-4D97-AF65-F5344CB8AC3E}">
-        <p14:creationId xmlns:p14="http://schemas.microsoft.com/office/powerpoint/2010/main" val="348494750"/>
+        <p14:creationId xmlns:p14="http://schemas.microsoft.com/office/powerpoint/2010/main" val="1191677237"/>
       </p:ext>
     </p:extLst>
   </p:cSld>
@@ -4772,7 +4772,7 @@
           <p:cNvPr id="1" name="Slide Number Placeholder 5">
             <a:extLst xmlns:a="http://schemas.openxmlformats.org/drawingml/2006/main">
               <a:ext uri="{FF2B5EF4-FFF2-40B4-BE49-F238E27FC236}">
-                <a16:creationId xmlns:a16="http://schemas.microsoft.com/office/drawing/2014/main" id="{77E5BACE-2531-45AD-B881-6DA5945DE19E}"/>
+                <a16:creationId xmlns:a16="http://schemas.microsoft.com/office/drawing/2014/main" id="{9E5C9098-3215-4B71-A866-2C5144D0CBAB}"/>
               </a:ext>
             </a:extLst>
           </p:cNvPr>
@@ -4804,7 +4804,7 @@
           <p:cNvPr id="2" name="">
             <a:extLst xmlns:a="http://schemas.openxmlformats.org/drawingml/2006/main">
               <a:ext uri="{FF2B5EF4-FFF2-40B4-BE49-F238E27FC236}">
-                <a16:creationId xmlns:a16="http://schemas.microsoft.com/office/drawing/2014/main" id="{D50201FE-12B0-43AB-9A2E-CF81C0C3AA51}"/>
+                <a16:creationId xmlns:a16="http://schemas.microsoft.com/office/drawing/2014/main" id="{8C1E0E50-1EFA-4505-92FC-B8E7FFA54117}"/>
               </a:ext>
             </a:extLst>
           </p:cNvPr>
@@ -4837,7 +4837,7 @@
           <p:cNvPr id="3" name="">
             <a:extLst xmlns:a="http://schemas.openxmlformats.org/drawingml/2006/main">
               <a:ext uri="{FF2B5EF4-FFF2-40B4-BE49-F238E27FC236}">
-                <a16:creationId xmlns:a16="http://schemas.microsoft.com/office/drawing/2014/main" id="{BFD469DD-A633-4E0F-AAE9-78959DE7EE4F}"/>
+                <a16:creationId xmlns:a16="http://schemas.microsoft.com/office/drawing/2014/main" id="{8B39FB48-13BC-4494-A311-438C8ABC4536}"/>
               </a:ext>
             </a:extLst>
           </p:cNvPr>
@@ -4870,7 +4870,7 @@
           <p:cNvPr id="4" name="">
             <a:extLst xmlns:a="http://schemas.openxmlformats.org/drawingml/2006/main">
               <a:ext uri="{FF2B5EF4-FFF2-40B4-BE49-F238E27FC236}">
-                <a16:creationId xmlns:a16="http://schemas.microsoft.com/office/drawing/2014/main" id="{48153793-F627-4B20-A3F4-BB0F365F0021}"/>
+                <a16:creationId xmlns:a16="http://schemas.microsoft.com/office/drawing/2014/main" id="{DF4127E2-C01E-4405-97EE-20071A4DB7A2}"/>
               </a:ext>
             </a:extLst>
           </p:cNvPr>
@@ -4930,7 +4930,7 @@
           <p:cNvPr id="5" name="">
             <a:extLst xmlns:a="http://schemas.openxmlformats.org/drawingml/2006/main">
               <a:ext uri="{FF2B5EF4-FFF2-40B4-BE49-F238E27FC236}">
-                <a16:creationId xmlns:a16="http://schemas.microsoft.com/office/drawing/2014/main" id="{1B2DDE4A-7024-4134-9284-424BE90EFB60}"/>
+                <a16:creationId xmlns:a16="http://schemas.microsoft.com/office/drawing/2014/main" id="{885FE8FC-2239-4722-8399-4DF40B565337}"/>
               </a:ext>
             </a:extLst>
           </p:cNvPr>
@@ -4990,7 +4990,7 @@
           <p:cNvPr id="6" name="">
             <a:extLst xmlns:a="http://schemas.openxmlformats.org/drawingml/2006/main">
               <a:ext uri="{FF2B5EF4-FFF2-40B4-BE49-F238E27FC236}">
-                <a16:creationId xmlns:a16="http://schemas.microsoft.com/office/drawing/2014/main" id="{0D7D05AE-800E-4450-8893-B4DB561F3321}"/>
+                <a16:creationId xmlns:a16="http://schemas.microsoft.com/office/drawing/2014/main" id="{4D00A542-E346-4DC7-AFDB-040A7B774F3D}"/>
               </a:ext>
             </a:extLst>
           </p:cNvPr>
@@ -5025,7 +5025,7 @@
           <p:cNvPr id="7" name="">
             <a:extLst xmlns:a="http://schemas.openxmlformats.org/drawingml/2006/main">
               <a:ext uri="{FF2B5EF4-FFF2-40B4-BE49-F238E27FC236}">
-                <a16:creationId xmlns:a16="http://schemas.microsoft.com/office/drawing/2014/main" id="{9C2049FA-6F82-4B25-8E9F-52F9EDC66C75}"/>
+                <a16:creationId xmlns:a16="http://schemas.microsoft.com/office/drawing/2014/main" id="{97D7A0B6-DFF5-47FB-A411-1C4911137C82}"/>
               </a:ext>
             </a:extLst>
           </p:cNvPr>
@@ -5085,7 +5085,7 @@
           <p:cNvPr id="8" name="">
             <a:extLst xmlns:a="http://schemas.openxmlformats.org/drawingml/2006/main">
               <a:ext uri="{FF2B5EF4-FFF2-40B4-BE49-F238E27FC236}">
-                <a16:creationId xmlns:a16="http://schemas.microsoft.com/office/drawing/2014/main" id="{A09599F1-0A8C-43CE-8610-BD3C02943350}"/>
+                <a16:creationId xmlns:a16="http://schemas.microsoft.com/office/drawing/2014/main" id="{F1CD95ED-89E9-4656-AA6F-3706DF55EFF5}"/>
               </a:ext>
             </a:extLst>
           </p:cNvPr>
@@ -5162,7 +5162,7 @@
           <p:cNvPr id="9" name="">
             <a:extLst xmlns:a="http://schemas.openxmlformats.org/drawingml/2006/main">
               <a:ext uri="{FF2B5EF4-FFF2-40B4-BE49-F238E27FC236}">
-                <a16:creationId xmlns:a16="http://schemas.microsoft.com/office/drawing/2014/main" id="{9B74067C-201C-4B2B-B0F2-5144359BAF66}"/>
+                <a16:creationId xmlns:a16="http://schemas.microsoft.com/office/drawing/2014/main" id="{5FE13967-CEC9-476E-80C9-263566C43BC0}"/>
               </a:ext>
             </a:extLst>
           </p:cNvPr>
@@ -5197,7 +5197,7 @@
           <p:cNvPr id="10" name="">
             <a:extLst xmlns:a="http://schemas.openxmlformats.org/drawingml/2006/main">
               <a:ext uri="{FF2B5EF4-FFF2-40B4-BE49-F238E27FC236}">
-                <a16:creationId xmlns:a16="http://schemas.microsoft.com/office/drawing/2014/main" id="{365D3C72-BB81-4BF3-8BEE-A67858733C49}"/>
+                <a16:creationId xmlns:a16="http://schemas.microsoft.com/office/drawing/2014/main" id="{B4C2B2A8-D2D2-458C-85E5-6A8D66CED0A2}"/>
               </a:ext>
             </a:extLst>
           </p:cNvPr>
@@ -5230,7 +5230,7 @@
           <p:cNvPr id="11" name="">
             <a:extLst xmlns:a="http://schemas.openxmlformats.org/drawingml/2006/main">
               <a:ext uri="{FF2B5EF4-FFF2-40B4-BE49-F238E27FC236}">
-                <a16:creationId xmlns:a16="http://schemas.microsoft.com/office/drawing/2014/main" id="{E2050F63-9C20-431E-86FC-F71B0916F26A}"/>
+                <a16:creationId xmlns:a16="http://schemas.microsoft.com/office/drawing/2014/main" id="{F48308BF-3A8D-4D3D-A344-F93E02E0B3F5}"/>
               </a:ext>
             </a:extLst>
           </p:cNvPr>
@@ -5290,7 +5290,7 @@
           <p:cNvPr id="12" name="">
             <a:extLst xmlns:a="http://schemas.openxmlformats.org/drawingml/2006/main">
               <a:ext uri="{FF2B5EF4-FFF2-40B4-BE49-F238E27FC236}">
-                <a16:creationId xmlns:a16="http://schemas.microsoft.com/office/drawing/2014/main" id="{391E0E3C-C076-4BEB-BF2A-05A95AEFFC43}"/>
+                <a16:creationId xmlns:a16="http://schemas.microsoft.com/office/drawing/2014/main" id="{64E86962-A63F-42DA-952E-A80F5310942B}"/>
               </a:ext>
             </a:extLst>
           </p:cNvPr>
@@ -5350,7 +5350,7 @@
           <p:cNvPr id="13" name="">
             <a:extLst xmlns:a="http://schemas.openxmlformats.org/drawingml/2006/main">
               <a:ext uri="{FF2B5EF4-FFF2-40B4-BE49-F238E27FC236}">
-                <a16:creationId xmlns:a16="http://schemas.microsoft.com/office/drawing/2014/main" id="{6FE173E5-5BA0-4CA5-9E4E-E77F5442A618}"/>
+                <a16:creationId xmlns:a16="http://schemas.microsoft.com/office/drawing/2014/main" id="{435AEB29-F599-4D9B-8CA3-B1115ED1B652}"/>
               </a:ext>
             </a:extLst>
           </p:cNvPr>
@@ -5385,7 +5385,7 @@
           <p:cNvPr id="14" name="">
             <a:extLst xmlns:a="http://schemas.openxmlformats.org/drawingml/2006/main">
               <a:ext uri="{FF2B5EF4-FFF2-40B4-BE49-F238E27FC236}">
-                <a16:creationId xmlns:a16="http://schemas.microsoft.com/office/drawing/2014/main" id="{0E13B081-E9B8-433A-BE8B-D3042078C7BC}"/>
+                <a16:creationId xmlns:a16="http://schemas.microsoft.com/office/drawing/2014/main" id="{54649B38-F784-42ED-9255-5B8A28A528C5}"/>
               </a:ext>
             </a:extLst>
           </p:cNvPr>
@@ -5418,7 +5418,7 @@
           <p:cNvPr id="15" name="">
             <a:extLst xmlns:a="http://schemas.openxmlformats.org/drawingml/2006/main">
               <a:ext uri="{FF2B5EF4-FFF2-40B4-BE49-F238E27FC236}">
-                <a16:creationId xmlns:a16="http://schemas.microsoft.com/office/drawing/2014/main" id="{FAD0B97C-9A1A-4951-B2C5-EB5C4FAF9A77}"/>
+                <a16:creationId xmlns:a16="http://schemas.microsoft.com/office/drawing/2014/main" id="{85CF09E1-E769-43A2-95E3-91E4C2F892FD}"/>
               </a:ext>
             </a:extLst>
           </p:cNvPr>
@@ -5478,7 +5478,7 @@
           <p:cNvPr id="16" name="">
             <a:extLst xmlns:a="http://schemas.openxmlformats.org/drawingml/2006/main">
               <a:ext uri="{FF2B5EF4-FFF2-40B4-BE49-F238E27FC236}">
-                <a16:creationId xmlns:a16="http://schemas.microsoft.com/office/drawing/2014/main" id="{E28082D2-86AE-4A61-85A4-0B743EDC467D}"/>
+                <a16:creationId xmlns:a16="http://schemas.microsoft.com/office/drawing/2014/main" id="{14A34B06-E064-495D-8C48-D17A15079C81}"/>
               </a:ext>
             </a:extLst>
           </p:cNvPr>
@@ -5538,23 +5538,23 @@
           <p:cNvPr id="17" name="">
             <a:extLst xmlns:a="http://schemas.openxmlformats.org/drawingml/2006/main">
               <a:ext uri="{FF2B5EF4-FFF2-40B4-BE49-F238E27FC236}">
-                <a16:creationId xmlns:a16="http://schemas.microsoft.com/office/drawing/2014/main" id="{C7DC7EB7-CCF0-40D4-A19E-64F5BA2E5083}"/>
-              </a:ext>
-            </a:extLst>
-          </p:cNvPr>
-          <p:cNvSpPr>
-            <a:spLocks xmlns:a="http://schemas.openxmlformats.org/drawingml/2006/main" noGrp="1"/>
-          </p:cNvSpPr>
-          <p:nvPr/>
-        </p:nvSpPr>
-        <p:spPr>
-          <a:xfrm xmlns:a="http://schemas.openxmlformats.org/drawingml/2006/main">
-            <a:off x="685800" y="4648200"/>
-            <a:ext cx="5048250" cy="990600"/>
+                <a16:creationId xmlns:a16="http://schemas.microsoft.com/office/drawing/2014/main" id="{F60FE6F8-759C-42FC-90D5-C318AD7AAE47}"/>
+              </a:ext>
+            </a:extLst>
+          </p:cNvPr>
+          <p:cNvSpPr>
+            <a:spLocks xmlns:a="http://schemas.openxmlformats.org/drawingml/2006/main" noGrp="1"/>
+          </p:cNvSpPr>
+          <p:nvPr/>
+        </p:nvSpPr>
+        <p:spPr>
+          <a:xfrm xmlns:a="http://schemas.openxmlformats.org/drawingml/2006/main">
+            <a:off x="685800" y="4572000"/>
+            <a:ext cx="5048250" cy="1219200"/>
           </a:xfrm>
           <a:prstGeom xmlns:a="http://schemas.openxmlformats.org/drawingml/2006/main" prst="roundRect">
             <a:avLst>
-              <a:gd name="adj" fmla="val 7692"/>
+              <a:gd name="adj" fmla="val 6250"/>
             </a:avLst>
           </a:prstGeom>
           <a:solidFill xmlns:a="http://schemas.openxmlformats.org/drawingml/2006/main">
@@ -5573,19 +5573,19 @@
           <p:cNvPr id="18" name="">
             <a:extLst xmlns:a="http://schemas.openxmlformats.org/drawingml/2006/main">
               <a:ext uri="{FF2B5EF4-FFF2-40B4-BE49-F238E27FC236}">
-                <a16:creationId xmlns:a16="http://schemas.microsoft.com/office/drawing/2014/main" id="{54A81FEC-C882-4767-A154-B88DD6FE044A}"/>
-              </a:ext>
-            </a:extLst>
-          </p:cNvPr>
-          <p:cNvSpPr>
-            <a:spLocks xmlns:a="http://schemas.openxmlformats.org/drawingml/2006/main" noGrp="1"/>
-          </p:cNvSpPr>
-          <p:nvPr/>
-        </p:nvSpPr>
-        <p:spPr>
-          <a:xfrm xmlns:a="http://schemas.openxmlformats.org/drawingml/2006/main">
-            <a:off x="685800" y="4648200"/>
-            <a:ext cx="76200" cy="990600"/>
+                <a16:creationId xmlns:a16="http://schemas.microsoft.com/office/drawing/2014/main" id="{743E4D97-CC0E-4E05-BE1E-B8D7CFE09D3A}"/>
+              </a:ext>
+            </a:extLst>
+          </p:cNvPr>
+          <p:cNvSpPr>
+            <a:spLocks xmlns:a="http://schemas.openxmlformats.org/drawingml/2006/main" noGrp="1"/>
+          </p:cNvSpPr>
+          <p:nvPr/>
+        </p:nvSpPr>
+        <p:spPr>
+          <a:xfrm xmlns:a="http://schemas.openxmlformats.org/drawingml/2006/main">
+            <a:off x="685800" y="4572000"/>
+            <a:ext cx="76200" cy="1219200"/>
           </a:xfrm>
           <a:prstGeom xmlns:a="http://schemas.openxmlformats.org/drawingml/2006/main" prst="rect">
             <a:avLst/>
@@ -5606,18 +5606,18 @@
           <p:cNvPr id="19" name="">
             <a:extLst xmlns:a="http://schemas.openxmlformats.org/drawingml/2006/main">
               <a:ext uri="{FF2B5EF4-FFF2-40B4-BE49-F238E27FC236}">
-                <a16:creationId xmlns:a16="http://schemas.microsoft.com/office/drawing/2014/main" id="{BB1BD036-5B57-450F-B61A-8D71B4CAC287}"/>
-              </a:ext>
-            </a:extLst>
-          </p:cNvPr>
-          <p:cNvSpPr>
-            <a:spLocks xmlns:a="http://schemas.openxmlformats.org/drawingml/2006/main" noGrp="1"/>
-          </p:cNvSpPr>
-          <p:nvPr/>
-        </p:nvSpPr>
-        <p:spPr>
-          <a:xfrm xmlns:a="http://schemas.openxmlformats.org/drawingml/2006/main">
-            <a:off x="914400" y="4857750"/>
+                <a16:creationId xmlns:a16="http://schemas.microsoft.com/office/drawing/2014/main" id="{FA927091-582D-4E9E-A3CA-0553A4B736BA}"/>
+              </a:ext>
+            </a:extLst>
+          </p:cNvPr>
+          <p:cNvSpPr>
+            <a:spLocks xmlns:a="http://schemas.openxmlformats.org/drawingml/2006/main" noGrp="1"/>
+          </p:cNvSpPr>
+          <p:nvPr/>
+        </p:nvSpPr>
+        <p:spPr>
+          <a:xfrm xmlns:a="http://schemas.openxmlformats.org/drawingml/2006/main">
+            <a:off x="914400" y="4781550"/>
             <a:ext cx="4591050" cy="285750"/>
           </a:xfrm>
           <a:prstGeom xmlns:a="http://schemas.openxmlformats.org/drawingml/2006/main" prst="rect">
@@ -5666,19 +5666,19 @@
           <p:cNvPr id="20" name="">
             <a:extLst xmlns:a="http://schemas.openxmlformats.org/drawingml/2006/main">
               <a:ext uri="{FF2B5EF4-FFF2-40B4-BE49-F238E27FC236}">
-                <a16:creationId xmlns:a16="http://schemas.microsoft.com/office/drawing/2014/main" id="{919EB375-3E1E-4B9D-B7E0-F1E4DAD0DD98}"/>
-              </a:ext>
-            </a:extLst>
-          </p:cNvPr>
-          <p:cNvSpPr>
-            <a:spLocks xmlns:a="http://schemas.openxmlformats.org/drawingml/2006/main" noGrp="1"/>
-          </p:cNvSpPr>
-          <p:nvPr/>
-        </p:nvSpPr>
-        <p:spPr>
-          <a:xfrm xmlns:a="http://schemas.openxmlformats.org/drawingml/2006/main">
-            <a:off x="914400" y="5295900"/>
-            <a:ext cx="4591050" cy="152400"/>
+                <a16:creationId xmlns:a16="http://schemas.microsoft.com/office/drawing/2014/main" id="{DF86BFCF-9AA2-4A12-9359-77F0E557BD78}"/>
+              </a:ext>
+            </a:extLst>
+          </p:cNvPr>
+          <p:cNvSpPr>
+            <a:spLocks xmlns:a="http://schemas.openxmlformats.org/drawingml/2006/main" noGrp="1"/>
+          </p:cNvSpPr>
+          <p:nvPr/>
+        </p:nvSpPr>
+        <p:spPr>
+          <a:xfrm xmlns:a="http://schemas.openxmlformats.org/drawingml/2006/main">
+            <a:off x="914400" y="5219700"/>
+            <a:ext cx="4591050" cy="381000"/>
           </a:xfrm>
           <a:prstGeom xmlns:a="http://schemas.openxmlformats.org/drawingml/2006/main" prst="rect">
             <a:avLst/>
@@ -5699,7 +5699,7 @@
         </p:spPr>
         <p:txBody>
           <a:bodyPr xmlns:a="http://schemas.openxmlformats.org/drawingml/2006/main" lIns="0" tIns="0" rIns="0" bIns="0" anchor="t">
-            <a:normAutofit fontScale="67841"/>
+            <a:normAutofit fontScale="100000"/>
           </a:bodyPr>
           <a:lstStyle xmlns:a="http://schemas.openxmlformats.org/drawingml/2006/main"/>
           <a:p xmlns:a="http://schemas.openxmlformats.org/drawingml/2006/main">
@@ -5716,7 +5716,24 @@
                   <a:srgbClr val="0F172A"/>
                 </a:solidFill>
               </a:rPr>
-              <a:t>Desktop does not support direct movement inside the hierarchy panel; items must be adjusted on the dashboard canvas.</a:t>
+              <a:t>Desktop does not support direct movement inside the hierarchy panel;</a:t>
+            </a:r>
+          </a:p>
+          <a:p xmlns:a="http://schemas.openxmlformats.org/drawingml/2006/main">
+            <a:pPr algn="l">
+              <a:defRPr sz="1088" b="0">
+                <a:solidFill>
+                  <a:srgbClr val="0F172A"/>
+                </a:solidFill>
+              </a:defRPr>
+            </a:pPr>
+            <a:r>
+              <a:rPr sz="1088" b="0">
+                <a:solidFill>
+                  <a:srgbClr val="0F172A"/>
+                </a:solidFill>
+              </a:rPr>
+              <a:t>items must be adjusted on the dashboard canvas.</a:t>
             </a:r>
           </a:p>
         </p:txBody>
@@ -5730,7 +5747,7 @@
           <p:nvPr/>
         </p:nvPicPr>
         <p:blipFill>
-          <a:blip xmlns:r="http://schemas.openxmlformats.org/officeDocument/2006/relationships" xmlns:a="http://schemas.openxmlformats.org/drawingml/2006/main" r:embed="R8c91d8cc27be4a1c"/>
+          <a:blip xmlns:r="http://schemas.openxmlformats.org/officeDocument/2006/relationships" xmlns:a="http://schemas.openxmlformats.org/drawingml/2006/main" r:embed="R9a1712bb33ab4207"/>
           <a:stretch xmlns:a="http://schemas.openxmlformats.org/drawingml/2006/main"/>
         </p:blipFill>
         <p:spPr>
@@ -5752,7 +5769,7 @@
           <p:nvPr/>
         </p:nvPicPr>
         <p:blipFill>
-          <a:blip xmlns:r="http://schemas.openxmlformats.org/officeDocument/2006/relationships" xmlns:a="http://schemas.openxmlformats.org/drawingml/2006/main" r:embed="Rb52972f68c694f2b"/>
+          <a:blip xmlns:r="http://schemas.openxmlformats.org/officeDocument/2006/relationships" xmlns:a="http://schemas.openxmlformats.org/drawingml/2006/main" r:embed="Rc61884138a3b4e41"/>
           <a:stretch xmlns:a="http://schemas.openxmlformats.org/drawingml/2006/main"/>
         </p:blipFill>
         <p:spPr>
@@ -5770,7 +5787,7 @@
           <p:cNvPr id="23" name="">
             <a:extLst xmlns:a="http://schemas.openxmlformats.org/drawingml/2006/main">
               <a:ext uri="{FF2B5EF4-FFF2-40B4-BE49-F238E27FC236}">
-                <a16:creationId xmlns:a16="http://schemas.microsoft.com/office/drawing/2014/main" id="{2AD2CFDD-417C-4DE9-9BF9-FB152B023107}"/>
+                <a16:creationId xmlns:a16="http://schemas.microsoft.com/office/drawing/2014/main" id="{2F6FAF36-5BA3-4EFA-BFBF-462C828BCF33}"/>
               </a:ext>
             </a:extLst>
           </p:cNvPr>
@@ -5808,14 +5825,14 @@
           <a:lstStyle xmlns:a="http://schemas.openxmlformats.org/drawingml/2006/main"/>
           <a:p xmlns:a="http://schemas.openxmlformats.org/drawingml/2006/main">
             <a:pPr algn="l">
-              <a:defRPr sz="863" b="1">
+              <a:defRPr sz="938" b="1">
                 <a:solidFill>
                   <a:srgbClr val="2CB1BC"/>
                 </a:solidFill>
               </a:defRPr>
             </a:pPr>
             <a:r>
-              <a:rPr sz="863" b="1">
+              <a:rPr sz="938" b="1">
                 <a:solidFill>
                   <a:srgbClr val="2CB1BC"/>
                 </a:solidFill>
@@ -5830,7 +5847,7 @@
           <p:cNvPr id="24" name="">
             <a:extLst xmlns:a="http://schemas.openxmlformats.org/drawingml/2006/main">
               <a:ext uri="{FF2B5EF4-FFF2-40B4-BE49-F238E27FC236}">
-                <a16:creationId xmlns:a16="http://schemas.microsoft.com/office/drawing/2014/main" id="{5FAA8D3C-9B6C-4BAC-B5FD-5BEBB590E24B}"/>
+                <a16:creationId xmlns:a16="http://schemas.microsoft.com/office/drawing/2014/main" id="{DA28F85C-6BE1-495D-A9D8-416BE3744164}"/>
               </a:ext>
             </a:extLst>
           </p:cNvPr>
@@ -5868,14 +5885,14 @@
           <a:lstStyle xmlns:a="http://schemas.openxmlformats.org/drawingml/2006/main"/>
           <a:p xmlns:a="http://schemas.openxmlformats.org/drawingml/2006/main">
             <a:pPr algn="l">
-              <a:defRPr sz="863" b="1">
+              <a:defRPr sz="938" b="1">
                 <a:solidFill>
                   <a:srgbClr val="5B67D8"/>
                 </a:solidFill>
               </a:defRPr>
             </a:pPr>
             <a:r>
-              <a:rPr sz="863" b="1">
+              <a:rPr sz="938" b="1">
                 <a:solidFill>
                   <a:srgbClr val="5B67D8"/>
                 </a:solidFill>
@@ -5890,19 +5907,19 @@
           <p:cNvPr id="25" name="">
             <a:extLst xmlns:a="http://schemas.openxmlformats.org/drawingml/2006/main">
               <a:ext uri="{FF2B5EF4-FFF2-40B4-BE49-F238E27FC236}">
-                <a16:creationId xmlns:a16="http://schemas.microsoft.com/office/drawing/2014/main" id="{23F87523-2793-4223-82E3-27FC6BC6DFB9}"/>
-              </a:ext>
-            </a:extLst>
-          </p:cNvPr>
-          <p:cNvSpPr>
-            <a:spLocks xmlns:a="http://schemas.openxmlformats.org/drawingml/2006/main" noGrp="1"/>
-          </p:cNvSpPr>
-          <p:nvPr/>
-        </p:nvSpPr>
-        <p:spPr>
-          <a:xfrm xmlns:a="http://schemas.openxmlformats.org/drawingml/2006/main">
-            <a:off x="514350" y="6400800"/>
-            <a:ext cx="8572500" cy="171450"/>
+                <a16:creationId xmlns:a16="http://schemas.microsoft.com/office/drawing/2014/main" id="{CB093C94-EB06-46E2-81FA-3107B6F3EF05}"/>
+              </a:ext>
+            </a:extLst>
+          </p:cNvPr>
+          <p:cNvSpPr>
+            <a:spLocks xmlns:a="http://schemas.openxmlformats.org/drawingml/2006/main" noGrp="1"/>
+          </p:cNvSpPr>
+          <p:nvPr/>
+        </p:nvSpPr>
+        <p:spPr>
+          <a:xfrm xmlns:a="http://schemas.openxmlformats.org/drawingml/2006/main">
+            <a:off x="514350" y="6381750"/>
+            <a:ext cx="8763000" cy="190500"/>
           </a:xfrm>
           <a:prstGeom xmlns:a="http://schemas.openxmlformats.org/drawingml/2006/main" prst="rect">
             <a:avLst/>
@@ -5928,14 +5945,14 @@
           <a:lstStyle xmlns:a="http://schemas.openxmlformats.org/drawingml/2006/main"/>
           <a:p xmlns:a="http://schemas.openxmlformats.org/drawingml/2006/main">
             <a:pPr algn="l">
-              <a:defRPr sz="713" b="0">
+              <a:defRPr sz="825" b="0">
                 <a:solidFill>
                   <a:srgbClr val="475569"/>
                 </a:solidFill>
               </a:defRPr>
             </a:pPr>
             <a:r>
-              <a:rPr sz="713" b="0">
+              <a:rPr sz="825" b="0">
                 <a:solidFill>
                   <a:srgbClr val="475569"/>
                 </a:solidFill>
@@ -5950,19 +5967,19 @@
           <p:cNvPr id="26" name="">
             <a:extLst xmlns:a="http://schemas.openxmlformats.org/drawingml/2006/main">
               <a:ext uri="{FF2B5EF4-FFF2-40B4-BE49-F238E27FC236}">
-                <a16:creationId xmlns:a16="http://schemas.microsoft.com/office/drawing/2014/main" id="{889EA544-9261-4C03-A701-8B97092D185B}"/>
-              </a:ext>
-            </a:extLst>
-          </p:cNvPr>
-          <p:cNvSpPr>
-            <a:spLocks xmlns:a="http://schemas.openxmlformats.org/drawingml/2006/main" noGrp="1"/>
-          </p:cNvSpPr>
-          <p:nvPr/>
-        </p:nvSpPr>
-        <p:spPr>
-          <a:xfrm xmlns:a="http://schemas.openxmlformats.org/drawingml/2006/main">
-            <a:off x="11049000" y="6400800"/>
-            <a:ext cx="628650" cy="171450"/>
+                <a16:creationId xmlns:a16="http://schemas.microsoft.com/office/drawing/2014/main" id="{31FE1236-7D27-4BDC-B44D-893482CBEC25}"/>
+              </a:ext>
+            </a:extLst>
+          </p:cNvPr>
+          <p:cNvSpPr>
+            <a:spLocks xmlns:a="http://schemas.openxmlformats.org/drawingml/2006/main" noGrp="1"/>
+          </p:cNvSpPr>
+          <p:nvPr/>
+        </p:nvSpPr>
+        <p:spPr>
+          <a:xfrm xmlns:a="http://schemas.openxmlformats.org/drawingml/2006/main">
+            <a:off x="11049000" y="6381750"/>
+            <a:ext cx="628650" cy="190500"/>
           </a:xfrm>
           <a:prstGeom xmlns:a="http://schemas.openxmlformats.org/drawingml/2006/main" prst="rect">
             <a:avLst/>
@@ -5988,14 +6005,14 @@
           <a:lstStyle xmlns:a="http://schemas.openxmlformats.org/drawingml/2006/main"/>
           <a:p xmlns:a="http://schemas.openxmlformats.org/drawingml/2006/main">
             <a:pPr algn="r">
-              <a:defRPr sz="750" b="0">
+              <a:defRPr sz="825" b="0">
                 <a:solidFill>
                   <a:srgbClr val="475569"/>
                 </a:solidFill>
               </a:defRPr>
             </a:pPr>
             <a:r>
-              <a:rPr sz="750" b="0">
+              <a:rPr sz="825" b="0">
                 <a:solidFill>
                   <a:srgbClr val="475569"/>
                 </a:solidFill>
@@ -6008,7 +6025,7 @@
     </p:spTree>
     <p:extLst>
       <p:ext uri="{BB962C8B-B14F-4D97-AF65-F5344CB8AC3E}">
-        <p14:creationId xmlns:p14="http://schemas.microsoft.com/office/powerpoint/2010/main" val="2088485383"/>
+        <p14:creationId xmlns:p14="http://schemas.microsoft.com/office/powerpoint/2010/main" val="1393485859"/>
       </p:ext>
     </p:extLst>
   </p:cSld>
@@ -6039,7 +6056,7 @@
           <p:cNvPr id="1" name="Slide Number Placeholder 5">
             <a:extLst xmlns:a="http://schemas.openxmlformats.org/drawingml/2006/main">
               <a:ext uri="{FF2B5EF4-FFF2-40B4-BE49-F238E27FC236}">
-                <a16:creationId xmlns:a16="http://schemas.microsoft.com/office/drawing/2014/main" id="{77E5BACE-2531-45AD-B881-6DA5945DE19E}"/>
+                <a16:creationId xmlns:a16="http://schemas.microsoft.com/office/drawing/2014/main" id="{9E5C9098-3215-4B71-A866-2C5144D0CBAB}"/>
               </a:ext>
             </a:extLst>
           </p:cNvPr>
@@ -6071,7 +6088,7 @@
           <p:cNvPr id="2" name="">
             <a:extLst xmlns:a="http://schemas.openxmlformats.org/drawingml/2006/main">
               <a:ext uri="{FF2B5EF4-FFF2-40B4-BE49-F238E27FC236}">
-                <a16:creationId xmlns:a16="http://schemas.microsoft.com/office/drawing/2014/main" id="{9CE774E6-D8AE-49F9-856B-AFA4FABB885D}"/>
+                <a16:creationId xmlns:a16="http://schemas.microsoft.com/office/drawing/2014/main" id="{A542B46E-4DEE-445E-B916-BDEEBB199EAA}"/>
               </a:ext>
             </a:extLst>
           </p:cNvPr>
@@ -6104,7 +6121,7 @@
           <p:cNvPr id="3" name="">
             <a:extLst xmlns:a="http://schemas.openxmlformats.org/drawingml/2006/main">
               <a:ext uri="{FF2B5EF4-FFF2-40B4-BE49-F238E27FC236}">
-                <a16:creationId xmlns:a16="http://schemas.microsoft.com/office/drawing/2014/main" id="{AA17B76D-2B3E-4BB3-96F9-EB4B9C8BF2D4}"/>
+                <a16:creationId xmlns:a16="http://schemas.microsoft.com/office/drawing/2014/main" id="{E82867A3-6C16-46F2-A150-967930C7714A}"/>
               </a:ext>
             </a:extLst>
           </p:cNvPr>
@@ -6137,7 +6154,7 @@
           <p:cNvPr id="4" name="">
             <a:extLst xmlns:a="http://schemas.openxmlformats.org/drawingml/2006/main">
               <a:ext uri="{FF2B5EF4-FFF2-40B4-BE49-F238E27FC236}">
-                <a16:creationId xmlns:a16="http://schemas.microsoft.com/office/drawing/2014/main" id="{55E95B3D-2080-4EB5-A3BB-28EDAC70FE16}"/>
+                <a16:creationId xmlns:a16="http://schemas.microsoft.com/office/drawing/2014/main" id="{889E0292-4BBC-419C-A727-B02A0D4BFA69}"/>
               </a:ext>
             </a:extLst>
           </p:cNvPr>
@@ -6197,7 +6214,7 @@
           <p:cNvPr id="5" name="">
             <a:extLst xmlns:a="http://schemas.openxmlformats.org/drawingml/2006/main">
               <a:ext uri="{FF2B5EF4-FFF2-40B4-BE49-F238E27FC236}">
-                <a16:creationId xmlns:a16="http://schemas.microsoft.com/office/drawing/2014/main" id="{BBB975C7-B704-4D42-AA5C-C3EDA6262500}"/>
+                <a16:creationId xmlns:a16="http://schemas.microsoft.com/office/drawing/2014/main" id="{1E437B23-F6C4-4FEB-BB55-E1B2B9A00E9F}"/>
               </a:ext>
             </a:extLst>
           </p:cNvPr>
@@ -6257,7 +6274,7 @@
           <p:cNvPr id="6" name="">
             <a:extLst xmlns:a="http://schemas.openxmlformats.org/drawingml/2006/main">
               <a:ext uri="{FF2B5EF4-FFF2-40B4-BE49-F238E27FC236}">
-                <a16:creationId xmlns:a16="http://schemas.microsoft.com/office/drawing/2014/main" id="{528D8A8E-8735-4157-B004-E53F7C6D5CB0}"/>
+                <a16:creationId xmlns:a16="http://schemas.microsoft.com/office/drawing/2014/main" id="{A6EEBF9F-0DDD-4C19-B839-79B9B0D81824}"/>
               </a:ext>
             </a:extLst>
           </p:cNvPr>
@@ -6292,7 +6309,7 @@
           <p:cNvPr id="7" name="">
             <a:extLst xmlns:a="http://schemas.openxmlformats.org/drawingml/2006/main">
               <a:ext uri="{FF2B5EF4-FFF2-40B4-BE49-F238E27FC236}">
-                <a16:creationId xmlns:a16="http://schemas.microsoft.com/office/drawing/2014/main" id="{1475EC80-B91D-4D4A-87D3-B6042117268A}"/>
+                <a16:creationId xmlns:a16="http://schemas.microsoft.com/office/drawing/2014/main" id="{13648FDE-3B84-4254-8DD8-4E4C5543A74F}"/>
               </a:ext>
             </a:extLst>
           </p:cNvPr>
@@ -6352,7 +6369,7 @@
           <p:cNvPr id="8" name="">
             <a:extLst xmlns:a="http://schemas.openxmlformats.org/drawingml/2006/main">
               <a:ext uri="{FF2B5EF4-FFF2-40B4-BE49-F238E27FC236}">
-                <a16:creationId xmlns:a16="http://schemas.microsoft.com/office/drawing/2014/main" id="{CD8A87FF-AC15-4B01-A205-D47177A0143F}"/>
+                <a16:creationId xmlns:a16="http://schemas.microsoft.com/office/drawing/2014/main" id="{F58F59EC-A675-457B-B909-A6478AFD6751}"/>
               </a:ext>
             </a:extLst>
           </p:cNvPr>
@@ -6429,7 +6446,7 @@
           <p:cNvPr id="9" name="">
             <a:extLst xmlns:a="http://schemas.openxmlformats.org/drawingml/2006/main">
               <a:ext uri="{FF2B5EF4-FFF2-40B4-BE49-F238E27FC236}">
-                <a16:creationId xmlns:a16="http://schemas.microsoft.com/office/drawing/2014/main" id="{A8F12117-737D-4031-B03A-613C88E72554}"/>
+                <a16:creationId xmlns:a16="http://schemas.microsoft.com/office/drawing/2014/main" id="{DCD43C0C-448E-4875-8E4E-6FD5C8219F76}"/>
               </a:ext>
             </a:extLst>
           </p:cNvPr>
@@ -6464,7 +6481,7 @@
           <p:cNvPr id="10" name="">
             <a:extLst xmlns:a="http://schemas.openxmlformats.org/drawingml/2006/main">
               <a:ext uri="{FF2B5EF4-FFF2-40B4-BE49-F238E27FC236}">
-                <a16:creationId xmlns:a16="http://schemas.microsoft.com/office/drawing/2014/main" id="{37C1CC19-C884-4910-9442-715DA643FEC5}"/>
+                <a16:creationId xmlns:a16="http://schemas.microsoft.com/office/drawing/2014/main" id="{58130A9E-1B59-49D4-97F4-122532D2BB31}"/>
               </a:ext>
             </a:extLst>
           </p:cNvPr>
@@ -6497,7 +6514,7 @@
           <p:cNvPr id="11" name="">
             <a:extLst xmlns:a="http://schemas.openxmlformats.org/drawingml/2006/main">
               <a:ext uri="{FF2B5EF4-FFF2-40B4-BE49-F238E27FC236}">
-                <a16:creationId xmlns:a16="http://schemas.microsoft.com/office/drawing/2014/main" id="{1A4B27B0-7590-4BA4-8C1A-D39F525B7A48}"/>
+                <a16:creationId xmlns:a16="http://schemas.microsoft.com/office/drawing/2014/main" id="{FB655ECF-B4E8-45AC-A831-367B9929743B}"/>
               </a:ext>
             </a:extLst>
           </p:cNvPr>
@@ -6557,7 +6574,7 @@
           <p:cNvPr id="12" name="">
             <a:extLst xmlns:a="http://schemas.openxmlformats.org/drawingml/2006/main">
               <a:ext uri="{FF2B5EF4-FFF2-40B4-BE49-F238E27FC236}">
-                <a16:creationId xmlns:a16="http://schemas.microsoft.com/office/drawing/2014/main" id="{7FF8BFD2-D46B-4981-AB16-917A9F4BFA40}"/>
+                <a16:creationId xmlns:a16="http://schemas.microsoft.com/office/drawing/2014/main" id="{37A6EF27-E2F4-4730-89D2-13840AC6B3EC}"/>
               </a:ext>
             </a:extLst>
           </p:cNvPr>
@@ -6617,7 +6634,7 @@
           <p:cNvPr id="13" name="">
             <a:extLst xmlns:a="http://schemas.openxmlformats.org/drawingml/2006/main">
               <a:ext uri="{FF2B5EF4-FFF2-40B4-BE49-F238E27FC236}">
-                <a16:creationId xmlns:a16="http://schemas.microsoft.com/office/drawing/2014/main" id="{FDD265CE-8A49-4A37-853D-96B5C977C312}"/>
+                <a16:creationId xmlns:a16="http://schemas.microsoft.com/office/drawing/2014/main" id="{E329787B-5E34-42ED-885C-D8833D9128B0}"/>
               </a:ext>
             </a:extLst>
           </p:cNvPr>
@@ -6652,7 +6669,7 @@
           <p:cNvPr id="14" name="">
             <a:extLst xmlns:a="http://schemas.openxmlformats.org/drawingml/2006/main">
               <a:ext uri="{FF2B5EF4-FFF2-40B4-BE49-F238E27FC236}">
-                <a16:creationId xmlns:a16="http://schemas.microsoft.com/office/drawing/2014/main" id="{B9AD43E3-2454-4EB9-A261-A10C8663AABF}"/>
+                <a16:creationId xmlns:a16="http://schemas.microsoft.com/office/drawing/2014/main" id="{1DD80D5B-B06A-4079-85D3-E3ED63800A09}"/>
               </a:ext>
             </a:extLst>
           </p:cNvPr>
@@ -6685,7 +6702,7 @@
           <p:cNvPr id="15" name="">
             <a:extLst xmlns:a="http://schemas.openxmlformats.org/drawingml/2006/main">
               <a:ext uri="{FF2B5EF4-FFF2-40B4-BE49-F238E27FC236}">
-                <a16:creationId xmlns:a16="http://schemas.microsoft.com/office/drawing/2014/main" id="{0B2BC09F-4F85-4A3C-9CB5-55DE0E44C963}"/>
+                <a16:creationId xmlns:a16="http://schemas.microsoft.com/office/drawing/2014/main" id="{1F15BBDF-567C-4A4D-A49A-5055EFB8CA5C}"/>
               </a:ext>
             </a:extLst>
           </p:cNvPr>
@@ -6745,7 +6762,7 @@
           <p:cNvPr id="16" name="">
             <a:extLst xmlns:a="http://schemas.openxmlformats.org/drawingml/2006/main">
               <a:ext uri="{FF2B5EF4-FFF2-40B4-BE49-F238E27FC236}">
-                <a16:creationId xmlns:a16="http://schemas.microsoft.com/office/drawing/2014/main" id="{07E64D1C-1F2C-402E-8223-1A178BD63C41}"/>
+                <a16:creationId xmlns:a16="http://schemas.microsoft.com/office/drawing/2014/main" id="{13314A40-50F2-477C-9A86-7B5C73BF5715}"/>
               </a:ext>
             </a:extLst>
           </p:cNvPr>
@@ -6805,23 +6822,23 @@
           <p:cNvPr id="17" name="">
             <a:extLst xmlns:a="http://schemas.openxmlformats.org/drawingml/2006/main">
               <a:ext uri="{FF2B5EF4-FFF2-40B4-BE49-F238E27FC236}">
-                <a16:creationId xmlns:a16="http://schemas.microsoft.com/office/drawing/2014/main" id="{ABAB795C-75D2-40EA-A43A-FC65770A198F}"/>
-              </a:ext>
-            </a:extLst>
-          </p:cNvPr>
-          <p:cNvSpPr>
-            <a:spLocks xmlns:a="http://schemas.openxmlformats.org/drawingml/2006/main" noGrp="1"/>
-          </p:cNvSpPr>
-          <p:nvPr/>
-        </p:nvSpPr>
-        <p:spPr>
-          <a:xfrm xmlns:a="http://schemas.openxmlformats.org/drawingml/2006/main">
-            <a:off x="685800" y="4648200"/>
-            <a:ext cx="5048250" cy="990600"/>
+                <a16:creationId xmlns:a16="http://schemas.microsoft.com/office/drawing/2014/main" id="{4909775D-B659-4F32-8BD2-6D7835EEE7FB}"/>
+              </a:ext>
+            </a:extLst>
+          </p:cNvPr>
+          <p:cNvSpPr>
+            <a:spLocks xmlns:a="http://schemas.openxmlformats.org/drawingml/2006/main" noGrp="1"/>
+          </p:cNvSpPr>
+          <p:nvPr/>
+        </p:nvSpPr>
+        <p:spPr>
+          <a:xfrm xmlns:a="http://schemas.openxmlformats.org/drawingml/2006/main">
+            <a:off x="685800" y="4572000"/>
+            <a:ext cx="5048250" cy="1219200"/>
           </a:xfrm>
           <a:prstGeom xmlns:a="http://schemas.openxmlformats.org/drawingml/2006/main" prst="roundRect">
             <a:avLst>
-              <a:gd name="adj" fmla="val 7692"/>
+              <a:gd name="adj" fmla="val 6250"/>
             </a:avLst>
           </a:prstGeom>
           <a:solidFill xmlns:a="http://schemas.openxmlformats.org/drawingml/2006/main">
@@ -6840,19 +6857,19 @@
           <p:cNvPr id="18" name="">
             <a:extLst xmlns:a="http://schemas.openxmlformats.org/drawingml/2006/main">
               <a:ext uri="{FF2B5EF4-FFF2-40B4-BE49-F238E27FC236}">
-                <a16:creationId xmlns:a16="http://schemas.microsoft.com/office/drawing/2014/main" id="{CAA6E237-217C-4717-B6D8-8BAD843DEB75}"/>
-              </a:ext>
-            </a:extLst>
-          </p:cNvPr>
-          <p:cNvSpPr>
-            <a:spLocks xmlns:a="http://schemas.openxmlformats.org/drawingml/2006/main" noGrp="1"/>
-          </p:cNvSpPr>
-          <p:nvPr/>
-        </p:nvSpPr>
-        <p:spPr>
-          <a:xfrm xmlns:a="http://schemas.openxmlformats.org/drawingml/2006/main">
-            <a:off x="685800" y="4648200"/>
-            <a:ext cx="76200" cy="990600"/>
+                <a16:creationId xmlns:a16="http://schemas.microsoft.com/office/drawing/2014/main" id="{4B237C3D-470A-440D-919C-EBF7E80D19A1}"/>
+              </a:ext>
+            </a:extLst>
+          </p:cNvPr>
+          <p:cNvSpPr>
+            <a:spLocks xmlns:a="http://schemas.openxmlformats.org/drawingml/2006/main" noGrp="1"/>
+          </p:cNvSpPr>
+          <p:nvPr/>
+        </p:nvSpPr>
+        <p:spPr>
+          <a:xfrm xmlns:a="http://schemas.openxmlformats.org/drawingml/2006/main">
+            <a:off x="685800" y="4572000"/>
+            <a:ext cx="76200" cy="1219200"/>
           </a:xfrm>
           <a:prstGeom xmlns:a="http://schemas.openxmlformats.org/drawingml/2006/main" prst="rect">
             <a:avLst/>
@@ -6873,18 +6890,18 @@
           <p:cNvPr id="19" name="">
             <a:extLst xmlns:a="http://schemas.openxmlformats.org/drawingml/2006/main">
               <a:ext uri="{FF2B5EF4-FFF2-40B4-BE49-F238E27FC236}">
-                <a16:creationId xmlns:a16="http://schemas.microsoft.com/office/drawing/2014/main" id="{D3541DA9-7F3A-4E1C-9B21-A71B0E12E8F1}"/>
-              </a:ext>
-            </a:extLst>
-          </p:cNvPr>
-          <p:cNvSpPr>
-            <a:spLocks xmlns:a="http://schemas.openxmlformats.org/drawingml/2006/main" noGrp="1"/>
-          </p:cNvSpPr>
-          <p:nvPr/>
-        </p:nvSpPr>
-        <p:spPr>
-          <a:xfrm xmlns:a="http://schemas.openxmlformats.org/drawingml/2006/main">
-            <a:off x="914400" y="4857750"/>
+                <a16:creationId xmlns:a16="http://schemas.microsoft.com/office/drawing/2014/main" id="{7C034939-2A93-4CE8-94B3-063D811A4814}"/>
+              </a:ext>
+            </a:extLst>
+          </p:cNvPr>
+          <p:cNvSpPr>
+            <a:spLocks xmlns:a="http://schemas.openxmlformats.org/drawingml/2006/main" noGrp="1"/>
+          </p:cNvSpPr>
+          <p:nvPr/>
+        </p:nvSpPr>
+        <p:spPr>
+          <a:xfrm xmlns:a="http://schemas.openxmlformats.org/drawingml/2006/main">
+            <a:off x="914400" y="4781550"/>
             <a:ext cx="4591050" cy="285750"/>
           </a:xfrm>
           <a:prstGeom xmlns:a="http://schemas.openxmlformats.org/drawingml/2006/main" prst="rect">
@@ -6933,19 +6950,19 @@
           <p:cNvPr id="20" name="">
             <a:extLst xmlns:a="http://schemas.openxmlformats.org/drawingml/2006/main">
               <a:ext uri="{FF2B5EF4-FFF2-40B4-BE49-F238E27FC236}">
-                <a16:creationId xmlns:a16="http://schemas.microsoft.com/office/drawing/2014/main" id="{93AAE08D-E5F1-4F3F-87EC-EF9A141F7314}"/>
-              </a:ext>
-            </a:extLst>
-          </p:cNvPr>
-          <p:cNvSpPr>
-            <a:spLocks xmlns:a="http://schemas.openxmlformats.org/drawingml/2006/main" noGrp="1"/>
-          </p:cNvSpPr>
-          <p:nvPr/>
-        </p:nvSpPr>
-        <p:spPr>
-          <a:xfrm xmlns:a="http://schemas.openxmlformats.org/drawingml/2006/main">
-            <a:off x="914400" y="5295900"/>
-            <a:ext cx="4591050" cy="152400"/>
+                <a16:creationId xmlns:a16="http://schemas.microsoft.com/office/drawing/2014/main" id="{EB8E658D-EF7E-4036-A3FA-9BE699667A4B}"/>
+              </a:ext>
+            </a:extLst>
+          </p:cNvPr>
+          <p:cNvSpPr>
+            <a:spLocks xmlns:a="http://schemas.openxmlformats.org/drawingml/2006/main" noGrp="1"/>
+          </p:cNvSpPr>
+          <p:nvPr/>
+        </p:nvSpPr>
+        <p:spPr>
+          <a:xfrm xmlns:a="http://schemas.openxmlformats.org/drawingml/2006/main">
+            <a:off x="914400" y="5219700"/>
+            <a:ext cx="4591050" cy="381000"/>
           </a:xfrm>
           <a:prstGeom xmlns:a="http://schemas.openxmlformats.org/drawingml/2006/main" prst="rect">
             <a:avLst/>
@@ -6966,7 +6983,7 @@
         </p:spPr>
         <p:txBody>
           <a:bodyPr xmlns:a="http://schemas.openxmlformats.org/drawingml/2006/main" lIns="0" tIns="0" rIns="0" bIns="0" anchor="t">
-            <a:normAutofit fontScale="90127"/>
+            <a:normAutofit fontScale="100000"/>
           </a:bodyPr>
           <a:lstStyle xmlns:a="http://schemas.openxmlformats.org/drawingml/2006/main"/>
           <a:p xmlns:a="http://schemas.openxmlformats.org/drawingml/2006/main">
@@ -6983,7 +7000,24 @@
                   <a:srgbClr val="0F172A"/>
                 </a:solidFill>
               </a:rPr>
-              <a:t>Cloud is enough for light edits; Desktop is better when tooltip readability must be polished.</a:t>
+              <a:t>Cloud is enough for light edits;</a:t>
+            </a:r>
+          </a:p>
+          <a:p xmlns:a="http://schemas.openxmlformats.org/drawingml/2006/main">
+            <a:pPr algn="l">
+              <a:defRPr sz="1088" b="0">
+                <a:solidFill>
+                  <a:srgbClr val="0F172A"/>
+                </a:solidFill>
+              </a:defRPr>
+            </a:pPr>
+            <a:r>
+              <a:rPr sz="1088" b="0">
+                <a:solidFill>
+                  <a:srgbClr val="0F172A"/>
+                </a:solidFill>
+              </a:rPr>
+              <a:t>Desktop is better when tooltip readability must be polished.</a:t>
             </a:r>
           </a:p>
         </p:txBody>
@@ -6997,7 +7031,7 @@
           <p:nvPr/>
         </p:nvPicPr>
         <p:blipFill>
-          <a:blip xmlns:r="http://schemas.openxmlformats.org/officeDocument/2006/relationships" xmlns:a="http://schemas.openxmlformats.org/drawingml/2006/main" r:embed="Ra1b8320426e142a0"/>
+          <a:blip xmlns:r="http://schemas.openxmlformats.org/officeDocument/2006/relationships" xmlns:a="http://schemas.openxmlformats.org/drawingml/2006/main" r:embed="R2da4419aa81545bc"/>
           <a:stretch xmlns:a="http://schemas.openxmlformats.org/drawingml/2006/main"/>
         </p:blipFill>
         <p:spPr>
@@ -7019,7 +7053,7 @@
           <p:nvPr/>
         </p:nvPicPr>
         <p:blipFill>
-          <a:blip xmlns:r="http://schemas.openxmlformats.org/officeDocument/2006/relationships" xmlns:a="http://schemas.openxmlformats.org/drawingml/2006/main" r:embed="R8b753f1d73734cb5"/>
+          <a:blip xmlns:r="http://schemas.openxmlformats.org/officeDocument/2006/relationships" xmlns:a="http://schemas.openxmlformats.org/drawingml/2006/main" r:embed="R9f6ca6dceea24293"/>
           <a:stretch xmlns:a="http://schemas.openxmlformats.org/drawingml/2006/main"/>
         </p:blipFill>
         <p:spPr>
@@ -7037,7 +7071,7 @@
           <p:cNvPr id="23" name="">
             <a:extLst xmlns:a="http://schemas.openxmlformats.org/drawingml/2006/main">
               <a:ext uri="{FF2B5EF4-FFF2-40B4-BE49-F238E27FC236}">
-                <a16:creationId xmlns:a16="http://schemas.microsoft.com/office/drawing/2014/main" id="{8C014BC8-845B-4988-B5D5-93855F43E78A}"/>
+                <a16:creationId xmlns:a16="http://schemas.microsoft.com/office/drawing/2014/main" id="{1BAD245C-A4A0-4518-87C3-11DE8ECE7A55}"/>
               </a:ext>
             </a:extLst>
           </p:cNvPr>
@@ -7075,14 +7109,14 @@
           <a:lstStyle xmlns:a="http://schemas.openxmlformats.org/drawingml/2006/main"/>
           <a:p xmlns:a="http://schemas.openxmlformats.org/drawingml/2006/main">
             <a:pPr algn="l">
-              <a:defRPr sz="863" b="1">
+              <a:defRPr sz="938" b="1">
                 <a:solidFill>
                   <a:srgbClr val="5B67D8"/>
                 </a:solidFill>
               </a:defRPr>
             </a:pPr>
             <a:r>
-              <a:rPr sz="863" b="1">
+              <a:rPr sz="938" b="1">
                 <a:solidFill>
                   <a:srgbClr val="5B67D8"/>
                 </a:solidFill>
@@ -7097,7 +7131,7 @@
           <p:cNvPr id="24" name="">
             <a:extLst xmlns:a="http://schemas.openxmlformats.org/drawingml/2006/main">
               <a:ext uri="{FF2B5EF4-FFF2-40B4-BE49-F238E27FC236}">
-                <a16:creationId xmlns:a16="http://schemas.microsoft.com/office/drawing/2014/main" id="{15647254-DA7E-49EA-866E-4BEAF7F04E77}"/>
+                <a16:creationId xmlns:a16="http://schemas.microsoft.com/office/drawing/2014/main" id="{BD79D9D3-F847-4040-9E06-061C8D176457}"/>
               </a:ext>
             </a:extLst>
           </p:cNvPr>
@@ -7135,14 +7169,14 @@
           <a:lstStyle xmlns:a="http://schemas.openxmlformats.org/drawingml/2006/main"/>
           <a:p xmlns:a="http://schemas.openxmlformats.org/drawingml/2006/main">
             <a:pPr algn="l">
-              <a:defRPr sz="863" b="1">
+              <a:defRPr sz="938" b="1">
                 <a:solidFill>
                   <a:srgbClr val="2CB1BC"/>
                 </a:solidFill>
               </a:defRPr>
             </a:pPr>
             <a:r>
-              <a:rPr sz="863" b="1">
+              <a:rPr sz="938" b="1">
                 <a:solidFill>
                   <a:srgbClr val="2CB1BC"/>
                 </a:solidFill>
@@ -7157,19 +7191,19 @@
           <p:cNvPr id="25" name="">
             <a:extLst xmlns:a="http://schemas.openxmlformats.org/drawingml/2006/main">
               <a:ext uri="{FF2B5EF4-FFF2-40B4-BE49-F238E27FC236}">
-                <a16:creationId xmlns:a16="http://schemas.microsoft.com/office/drawing/2014/main" id="{454882AE-CAD1-4EE8-B43A-6AB065AF34A2}"/>
-              </a:ext>
-            </a:extLst>
-          </p:cNvPr>
-          <p:cNvSpPr>
-            <a:spLocks xmlns:a="http://schemas.openxmlformats.org/drawingml/2006/main" noGrp="1"/>
-          </p:cNvSpPr>
-          <p:nvPr/>
-        </p:nvSpPr>
-        <p:spPr>
-          <a:xfrm xmlns:a="http://schemas.openxmlformats.org/drawingml/2006/main">
-            <a:off x="514350" y="6400800"/>
-            <a:ext cx="8572500" cy="171450"/>
+                <a16:creationId xmlns:a16="http://schemas.microsoft.com/office/drawing/2014/main" id="{C8A31F27-5B3A-47B2-9818-E91F3D6A5C9A}"/>
+              </a:ext>
+            </a:extLst>
+          </p:cNvPr>
+          <p:cNvSpPr>
+            <a:spLocks xmlns:a="http://schemas.openxmlformats.org/drawingml/2006/main" noGrp="1"/>
+          </p:cNvSpPr>
+          <p:nvPr/>
+        </p:nvSpPr>
+        <p:spPr>
+          <a:xfrm xmlns:a="http://schemas.openxmlformats.org/drawingml/2006/main">
+            <a:off x="514350" y="6381750"/>
+            <a:ext cx="8763000" cy="190500"/>
           </a:xfrm>
           <a:prstGeom xmlns:a="http://schemas.openxmlformats.org/drawingml/2006/main" prst="rect">
             <a:avLst/>
@@ -7195,14 +7229,14 @@
           <a:lstStyle xmlns:a="http://schemas.openxmlformats.org/drawingml/2006/main"/>
           <a:p xmlns:a="http://schemas.openxmlformats.org/drawingml/2006/main">
             <a:pPr algn="l">
-              <a:defRPr sz="713" b="0">
+              <a:defRPr sz="825" b="0">
                 <a:solidFill>
                   <a:srgbClr val="475569"/>
                 </a:solidFill>
               </a:defRPr>
             </a:pPr>
             <a:r>
-              <a:rPr sz="713" b="0">
+              <a:rPr sz="825" b="0">
                 <a:solidFill>
                   <a:srgbClr val="475569"/>
                 </a:solidFill>
@@ -7217,19 +7251,19 @@
           <p:cNvPr id="26" name="">
             <a:extLst xmlns:a="http://schemas.openxmlformats.org/drawingml/2006/main">
               <a:ext uri="{FF2B5EF4-FFF2-40B4-BE49-F238E27FC236}">
-                <a16:creationId xmlns:a16="http://schemas.microsoft.com/office/drawing/2014/main" id="{307ECDC0-5AF9-4C44-9198-C2FD12F5E19F}"/>
-              </a:ext>
-            </a:extLst>
-          </p:cNvPr>
-          <p:cNvSpPr>
-            <a:spLocks xmlns:a="http://schemas.openxmlformats.org/drawingml/2006/main" noGrp="1"/>
-          </p:cNvSpPr>
-          <p:nvPr/>
-        </p:nvSpPr>
-        <p:spPr>
-          <a:xfrm xmlns:a="http://schemas.openxmlformats.org/drawingml/2006/main">
-            <a:off x="11049000" y="6400800"/>
-            <a:ext cx="628650" cy="171450"/>
+                <a16:creationId xmlns:a16="http://schemas.microsoft.com/office/drawing/2014/main" id="{643D6B44-67B1-4F3E-8F61-7242C2BF8874}"/>
+              </a:ext>
+            </a:extLst>
+          </p:cNvPr>
+          <p:cNvSpPr>
+            <a:spLocks xmlns:a="http://schemas.openxmlformats.org/drawingml/2006/main" noGrp="1"/>
+          </p:cNvSpPr>
+          <p:nvPr/>
+        </p:nvSpPr>
+        <p:spPr>
+          <a:xfrm xmlns:a="http://schemas.openxmlformats.org/drawingml/2006/main">
+            <a:off x="11049000" y="6381750"/>
+            <a:ext cx="628650" cy="190500"/>
           </a:xfrm>
           <a:prstGeom xmlns:a="http://schemas.openxmlformats.org/drawingml/2006/main" prst="rect">
             <a:avLst/>
@@ -7255,14 +7289,14 @@
           <a:lstStyle xmlns:a="http://schemas.openxmlformats.org/drawingml/2006/main"/>
           <a:p xmlns:a="http://schemas.openxmlformats.org/drawingml/2006/main">
             <a:pPr algn="r">
-              <a:defRPr sz="750" b="0">
+              <a:defRPr sz="825" b="0">
                 <a:solidFill>
                   <a:srgbClr val="475569"/>
                 </a:solidFill>
               </a:defRPr>
             </a:pPr>
             <a:r>
-              <a:rPr sz="750" b="0">
+              <a:rPr sz="825" b="0">
                 <a:solidFill>
                   <a:srgbClr val="475569"/>
                 </a:solidFill>
@@ -7275,7 +7309,7 @@
     </p:spTree>
     <p:extLst>
       <p:ext uri="{BB962C8B-B14F-4D97-AF65-F5344CB8AC3E}">
-        <p14:creationId xmlns:p14="http://schemas.microsoft.com/office/powerpoint/2010/main" val="1956670519"/>
+        <p14:creationId xmlns:p14="http://schemas.microsoft.com/office/powerpoint/2010/main" val="1416454784"/>
       </p:ext>
     </p:extLst>
   </p:cSld>
@@ -7306,7 +7340,7 @@
           <p:cNvPr id="1" name="Slide Number Placeholder 5">
             <a:extLst xmlns:a="http://schemas.openxmlformats.org/drawingml/2006/main">
               <a:ext uri="{FF2B5EF4-FFF2-40B4-BE49-F238E27FC236}">
-                <a16:creationId xmlns:a16="http://schemas.microsoft.com/office/drawing/2014/main" id="{77E5BACE-2531-45AD-B881-6DA5945DE19E}"/>
+                <a16:creationId xmlns:a16="http://schemas.microsoft.com/office/drawing/2014/main" id="{9E5C9098-3215-4B71-A866-2C5144D0CBAB}"/>
               </a:ext>
             </a:extLst>
           </p:cNvPr>
@@ -7338,7 +7372,7 @@
           <p:cNvPr id="2" name="">
             <a:extLst xmlns:a="http://schemas.openxmlformats.org/drawingml/2006/main">
               <a:ext uri="{FF2B5EF4-FFF2-40B4-BE49-F238E27FC236}">
-                <a16:creationId xmlns:a16="http://schemas.microsoft.com/office/drawing/2014/main" id="{5FD22932-56C3-4CB0-A187-957CB30B5834}"/>
+                <a16:creationId xmlns:a16="http://schemas.microsoft.com/office/drawing/2014/main" id="{8EF1BE69-591C-416E-A041-28508776D34E}"/>
               </a:ext>
             </a:extLst>
           </p:cNvPr>
@@ -7371,7 +7405,7 @@
           <p:cNvPr id="3" name="">
             <a:extLst xmlns:a="http://schemas.openxmlformats.org/drawingml/2006/main">
               <a:ext uri="{FF2B5EF4-FFF2-40B4-BE49-F238E27FC236}">
-                <a16:creationId xmlns:a16="http://schemas.microsoft.com/office/drawing/2014/main" id="{8B624B2C-8A75-43CC-A5FB-2A9A4A1334F4}"/>
+                <a16:creationId xmlns:a16="http://schemas.microsoft.com/office/drawing/2014/main" id="{3F1731C1-AD1F-46E0-BAB2-53D06475A735}"/>
               </a:ext>
             </a:extLst>
           </p:cNvPr>
@@ -7404,7 +7438,7 @@
           <p:cNvPr id="4" name="">
             <a:extLst xmlns:a="http://schemas.openxmlformats.org/drawingml/2006/main">
               <a:ext uri="{FF2B5EF4-FFF2-40B4-BE49-F238E27FC236}">
-                <a16:creationId xmlns:a16="http://schemas.microsoft.com/office/drawing/2014/main" id="{5679FDF8-903F-4050-9AF6-1F0B15A51279}"/>
+                <a16:creationId xmlns:a16="http://schemas.microsoft.com/office/drawing/2014/main" id="{3102D53F-593F-4E2F-A0C8-C476153F2B2D}"/>
               </a:ext>
             </a:extLst>
           </p:cNvPr>
@@ -7464,7 +7498,7 @@
           <p:cNvPr id="5" name="">
             <a:extLst xmlns:a="http://schemas.openxmlformats.org/drawingml/2006/main">
               <a:ext uri="{FF2B5EF4-FFF2-40B4-BE49-F238E27FC236}">
-                <a16:creationId xmlns:a16="http://schemas.microsoft.com/office/drawing/2014/main" id="{7B5A342E-4A06-4ADA-A996-53457FB6781E}"/>
+                <a16:creationId xmlns:a16="http://schemas.microsoft.com/office/drawing/2014/main" id="{4E2EF1E9-3B07-4D70-9E12-E687BAC2FDAE}"/>
               </a:ext>
             </a:extLst>
           </p:cNvPr>
@@ -7524,7 +7558,7 @@
           <p:cNvPr id="6" name="">
             <a:extLst xmlns:a="http://schemas.openxmlformats.org/drawingml/2006/main">
               <a:ext uri="{FF2B5EF4-FFF2-40B4-BE49-F238E27FC236}">
-                <a16:creationId xmlns:a16="http://schemas.microsoft.com/office/drawing/2014/main" id="{583C8B16-B41E-4D77-A59D-62CF9B17927A}"/>
+                <a16:creationId xmlns:a16="http://schemas.microsoft.com/office/drawing/2014/main" id="{FC80B9D6-0BEA-44AC-B31C-55700EA0F1E6}"/>
               </a:ext>
             </a:extLst>
           </p:cNvPr>
@@ -7559,7 +7593,7 @@
           <p:cNvPr id="7" name="">
             <a:extLst xmlns:a="http://schemas.openxmlformats.org/drawingml/2006/main">
               <a:ext uri="{FF2B5EF4-FFF2-40B4-BE49-F238E27FC236}">
-                <a16:creationId xmlns:a16="http://schemas.microsoft.com/office/drawing/2014/main" id="{11092421-E97C-41A5-B248-C71A370719E4}"/>
+                <a16:creationId xmlns:a16="http://schemas.microsoft.com/office/drawing/2014/main" id="{98665E8D-C1F6-4772-8F3E-E91512E8E85F}"/>
               </a:ext>
             </a:extLst>
           </p:cNvPr>
@@ -7619,7 +7653,7 @@
           <p:cNvPr id="8" name="">
             <a:extLst xmlns:a="http://schemas.openxmlformats.org/drawingml/2006/main">
               <a:ext uri="{FF2B5EF4-FFF2-40B4-BE49-F238E27FC236}">
-                <a16:creationId xmlns:a16="http://schemas.microsoft.com/office/drawing/2014/main" id="{5D88EA32-27A5-4E5D-9066-91557C8AEB89}"/>
+                <a16:creationId xmlns:a16="http://schemas.microsoft.com/office/drawing/2014/main" id="{C999D8FF-0457-4786-8AC9-6CB9DAF325A8}"/>
               </a:ext>
             </a:extLst>
           </p:cNvPr>
@@ -7696,7 +7730,7 @@
           <p:cNvPr id="9" name="">
             <a:extLst xmlns:a="http://schemas.openxmlformats.org/drawingml/2006/main">
               <a:ext uri="{FF2B5EF4-FFF2-40B4-BE49-F238E27FC236}">
-                <a16:creationId xmlns:a16="http://schemas.microsoft.com/office/drawing/2014/main" id="{CC167073-F129-46F6-A093-1A10BB78A893}"/>
+                <a16:creationId xmlns:a16="http://schemas.microsoft.com/office/drawing/2014/main" id="{F36C2339-21A9-4A22-B8E8-AFEB2D43F4A9}"/>
               </a:ext>
             </a:extLst>
           </p:cNvPr>
@@ -7731,7 +7765,7 @@
           <p:cNvPr id="10" name="">
             <a:extLst xmlns:a="http://schemas.openxmlformats.org/drawingml/2006/main">
               <a:ext uri="{FF2B5EF4-FFF2-40B4-BE49-F238E27FC236}">
-                <a16:creationId xmlns:a16="http://schemas.microsoft.com/office/drawing/2014/main" id="{EFCEA95F-1AEA-46A5-A499-AE359315DDFC}"/>
+                <a16:creationId xmlns:a16="http://schemas.microsoft.com/office/drawing/2014/main" id="{EC2F65E1-9203-4940-B408-4A618944BA40}"/>
               </a:ext>
             </a:extLst>
           </p:cNvPr>
@@ -7764,7 +7798,7 @@
           <p:cNvPr id="11" name="">
             <a:extLst xmlns:a="http://schemas.openxmlformats.org/drawingml/2006/main">
               <a:ext uri="{FF2B5EF4-FFF2-40B4-BE49-F238E27FC236}">
-                <a16:creationId xmlns:a16="http://schemas.microsoft.com/office/drawing/2014/main" id="{94CDB53A-A676-4825-9CDE-E7411E9BD3A8}"/>
+                <a16:creationId xmlns:a16="http://schemas.microsoft.com/office/drawing/2014/main" id="{428E7E5B-FB2E-4923-9208-DEE8FD8E336D}"/>
               </a:ext>
             </a:extLst>
           </p:cNvPr>
@@ -7824,7 +7858,7 @@
           <p:cNvPr id="12" name="">
             <a:extLst xmlns:a="http://schemas.openxmlformats.org/drawingml/2006/main">
               <a:ext uri="{FF2B5EF4-FFF2-40B4-BE49-F238E27FC236}">
-                <a16:creationId xmlns:a16="http://schemas.microsoft.com/office/drawing/2014/main" id="{2669F585-A549-44D7-AE35-0E711222FCB5}"/>
+                <a16:creationId xmlns:a16="http://schemas.microsoft.com/office/drawing/2014/main" id="{F71D24D3-734A-4B42-A811-763F214E9BCD}"/>
               </a:ext>
             </a:extLst>
           </p:cNvPr>
@@ -7884,7 +7918,7 @@
           <p:cNvPr id="13" name="">
             <a:extLst xmlns:a="http://schemas.openxmlformats.org/drawingml/2006/main">
               <a:ext uri="{FF2B5EF4-FFF2-40B4-BE49-F238E27FC236}">
-                <a16:creationId xmlns:a16="http://schemas.microsoft.com/office/drawing/2014/main" id="{1CC8D9A1-C162-46E2-8714-57F5C502F05D}"/>
+                <a16:creationId xmlns:a16="http://schemas.microsoft.com/office/drawing/2014/main" id="{A3769C5E-574B-424D-A3FA-2A0BD1F48976}"/>
               </a:ext>
             </a:extLst>
           </p:cNvPr>
@@ -7919,7 +7953,7 @@
           <p:cNvPr id="14" name="">
             <a:extLst xmlns:a="http://schemas.openxmlformats.org/drawingml/2006/main">
               <a:ext uri="{FF2B5EF4-FFF2-40B4-BE49-F238E27FC236}">
-                <a16:creationId xmlns:a16="http://schemas.microsoft.com/office/drawing/2014/main" id="{BDDC7465-ACC2-4946-B526-D2D4F2E29472}"/>
+                <a16:creationId xmlns:a16="http://schemas.microsoft.com/office/drawing/2014/main" id="{56C916D3-97C6-4BB4-8A2D-2F89A8C70C2B}"/>
               </a:ext>
             </a:extLst>
           </p:cNvPr>
@@ -7952,7 +7986,7 @@
           <p:cNvPr id="15" name="">
             <a:extLst xmlns:a="http://schemas.openxmlformats.org/drawingml/2006/main">
               <a:ext uri="{FF2B5EF4-FFF2-40B4-BE49-F238E27FC236}">
-                <a16:creationId xmlns:a16="http://schemas.microsoft.com/office/drawing/2014/main" id="{13A712E2-9CBE-4E53-99A3-73A974B84636}"/>
+                <a16:creationId xmlns:a16="http://schemas.microsoft.com/office/drawing/2014/main" id="{1EBBEE66-FB9B-45A5-9C24-73723E7B6002}"/>
               </a:ext>
             </a:extLst>
           </p:cNvPr>
@@ -8012,7 +8046,7 @@
           <p:cNvPr id="16" name="">
             <a:extLst xmlns:a="http://schemas.openxmlformats.org/drawingml/2006/main">
               <a:ext uri="{FF2B5EF4-FFF2-40B4-BE49-F238E27FC236}">
-                <a16:creationId xmlns:a16="http://schemas.microsoft.com/office/drawing/2014/main" id="{A47ACBF1-84FE-4087-B390-EF1A76C06D92}"/>
+                <a16:creationId xmlns:a16="http://schemas.microsoft.com/office/drawing/2014/main" id="{17632452-43B1-4CB6-B9CF-026443709276}"/>
               </a:ext>
             </a:extLst>
           </p:cNvPr>
@@ -8072,23 +8106,23 @@
           <p:cNvPr id="17" name="">
             <a:extLst xmlns:a="http://schemas.openxmlformats.org/drawingml/2006/main">
               <a:ext uri="{FF2B5EF4-FFF2-40B4-BE49-F238E27FC236}">
-                <a16:creationId xmlns:a16="http://schemas.microsoft.com/office/drawing/2014/main" id="{1ED4139E-B204-4FFD-B150-5A218ED6EB34}"/>
-              </a:ext>
-            </a:extLst>
-          </p:cNvPr>
-          <p:cNvSpPr>
-            <a:spLocks xmlns:a="http://schemas.openxmlformats.org/drawingml/2006/main" noGrp="1"/>
-          </p:cNvSpPr>
-          <p:nvPr/>
-        </p:nvSpPr>
-        <p:spPr>
-          <a:xfrm xmlns:a="http://schemas.openxmlformats.org/drawingml/2006/main">
-            <a:off x="685800" y="4648200"/>
-            <a:ext cx="5048250" cy="990600"/>
+                <a16:creationId xmlns:a16="http://schemas.microsoft.com/office/drawing/2014/main" id="{D0619C7F-215D-4E56-A968-169F13502287}"/>
+              </a:ext>
+            </a:extLst>
+          </p:cNvPr>
+          <p:cNvSpPr>
+            <a:spLocks xmlns:a="http://schemas.openxmlformats.org/drawingml/2006/main" noGrp="1"/>
+          </p:cNvSpPr>
+          <p:nvPr/>
+        </p:nvSpPr>
+        <p:spPr>
+          <a:xfrm xmlns:a="http://schemas.openxmlformats.org/drawingml/2006/main">
+            <a:off x="685800" y="4572000"/>
+            <a:ext cx="5048250" cy="1219200"/>
           </a:xfrm>
           <a:prstGeom xmlns:a="http://schemas.openxmlformats.org/drawingml/2006/main" prst="roundRect">
             <a:avLst>
-              <a:gd name="adj" fmla="val 7692"/>
+              <a:gd name="adj" fmla="val 6250"/>
             </a:avLst>
           </a:prstGeom>
           <a:solidFill xmlns:a="http://schemas.openxmlformats.org/drawingml/2006/main">
@@ -8107,19 +8141,19 @@
           <p:cNvPr id="18" name="">
             <a:extLst xmlns:a="http://schemas.openxmlformats.org/drawingml/2006/main">
               <a:ext uri="{FF2B5EF4-FFF2-40B4-BE49-F238E27FC236}">
-                <a16:creationId xmlns:a16="http://schemas.microsoft.com/office/drawing/2014/main" id="{1A727E82-D372-4980-A4B4-3C7534990CB8}"/>
-              </a:ext>
-            </a:extLst>
-          </p:cNvPr>
-          <p:cNvSpPr>
-            <a:spLocks xmlns:a="http://schemas.openxmlformats.org/drawingml/2006/main" noGrp="1"/>
-          </p:cNvSpPr>
-          <p:nvPr/>
-        </p:nvSpPr>
-        <p:spPr>
-          <a:xfrm xmlns:a="http://schemas.openxmlformats.org/drawingml/2006/main">
-            <a:off x="685800" y="4648200"/>
-            <a:ext cx="76200" cy="990600"/>
+                <a16:creationId xmlns:a16="http://schemas.microsoft.com/office/drawing/2014/main" id="{CCBBEC85-3AD8-4474-AABF-363EA46138DF}"/>
+              </a:ext>
+            </a:extLst>
+          </p:cNvPr>
+          <p:cNvSpPr>
+            <a:spLocks xmlns:a="http://schemas.openxmlformats.org/drawingml/2006/main" noGrp="1"/>
+          </p:cNvSpPr>
+          <p:nvPr/>
+        </p:nvSpPr>
+        <p:spPr>
+          <a:xfrm xmlns:a="http://schemas.openxmlformats.org/drawingml/2006/main">
+            <a:off x="685800" y="4572000"/>
+            <a:ext cx="76200" cy="1219200"/>
           </a:xfrm>
           <a:prstGeom xmlns:a="http://schemas.openxmlformats.org/drawingml/2006/main" prst="rect">
             <a:avLst/>
@@ -8140,18 +8174,18 @@
           <p:cNvPr id="19" name="">
             <a:extLst xmlns:a="http://schemas.openxmlformats.org/drawingml/2006/main">
               <a:ext uri="{FF2B5EF4-FFF2-40B4-BE49-F238E27FC236}">
-                <a16:creationId xmlns:a16="http://schemas.microsoft.com/office/drawing/2014/main" id="{2589520A-E7C7-45C5-BDF9-746E5CD9270D}"/>
-              </a:ext>
-            </a:extLst>
-          </p:cNvPr>
-          <p:cNvSpPr>
-            <a:spLocks xmlns:a="http://schemas.openxmlformats.org/drawingml/2006/main" noGrp="1"/>
-          </p:cNvSpPr>
-          <p:nvPr/>
-        </p:nvSpPr>
-        <p:spPr>
-          <a:xfrm xmlns:a="http://schemas.openxmlformats.org/drawingml/2006/main">
-            <a:off x="914400" y="4857750"/>
+                <a16:creationId xmlns:a16="http://schemas.microsoft.com/office/drawing/2014/main" id="{45255D0C-7EEB-46D0-98CE-9BBD5F20DC96}"/>
+              </a:ext>
+            </a:extLst>
+          </p:cNvPr>
+          <p:cNvSpPr>
+            <a:spLocks xmlns:a="http://schemas.openxmlformats.org/drawingml/2006/main" noGrp="1"/>
+          </p:cNvSpPr>
+          <p:nvPr/>
+        </p:nvSpPr>
+        <p:spPr>
+          <a:xfrm xmlns:a="http://schemas.openxmlformats.org/drawingml/2006/main">
+            <a:off x="914400" y="4781550"/>
             <a:ext cx="4591050" cy="285750"/>
           </a:xfrm>
           <a:prstGeom xmlns:a="http://schemas.openxmlformats.org/drawingml/2006/main" prst="rect">
@@ -8200,19 +8234,19 @@
           <p:cNvPr id="20" name="">
             <a:extLst xmlns:a="http://schemas.openxmlformats.org/drawingml/2006/main">
               <a:ext uri="{FF2B5EF4-FFF2-40B4-BE49-F238E27FC236}">
-                <a16:creationId xmlns:a16="http://schemas.microsoft.com/office/drawing/2014/main" id="{D3F7F8A5-B846-4783-9151-569C2623F415}"/>
-              </a:ext>
-            </a:extLst>
-          </p:cNvPr>
-          <p:cNvSpPr>
-            <a:spLocks xmlns:a="http://schemas.openxmlformats.org/drawingml/2006/main" noGrp="1"/>
-          </p:cNvSpPr>
-          <p:nvPr/>
-        </p:nvSpPr>
-        <p:spPr>
-          <a:xfrm xmlns:a="http://schemas.openxmlformats.org/drawingml/2006/main">
-            <a:off x="914400" y="5295900"/>
-            <a:ext cx="4591050" cy="152400"/>
+                <a16:creationId xmlns:a16="http://schemas.microsoft.com/office/drawing/2014/main" id="{24DD855C-C4D7-4FDB-BD64-8B9EEB029BE3}"/>
+              </a:ext>
+            </a:extLst>
+          </p:cNvPr>
+          <p:cNvSpPr>
+            <a:spLocks xmlns:a="http://schemas.openxmlformats.org/drawingml/2006/main" noGrp="1"/>
+          </p:cNvSpPr>
+          <p:nvPr/>
+        </p:nvSpPr>
+        <p:spPr>
+          <a:xfrm xmlns:a="http://schemas.openxmlformats.org/drawingml/2006/main">
+            <a:off x="914400" y="5219700"/>
+            <a:ext cx="4591050" cy="381000"/>
           </a:xfrm>
           <a:prstGeom xmlns:a="http://schemas.openxmlformats.org/drawingml/2006/main" prst="rect">
             <a:avLst/>
@@ -8233,7 +8267,7 @@
         </p:spPr>
         <p:txBody>
           <a:bodyPr xmlns:a="http://schemas.openxmlformats.org/drawingml/2006/main" lIns="0" tIns="0" rIns="0" bIns="0" anchor="t">
-            <a:normAutofit fontScale="85743"/>
+            <a:normAutofit fontScale="100000"/>
           </a:bodyPr>
           <a:lstStyle xmlns:a="http://schemas.openxmlformats.org/drawingml/2006/main"/>
           <a:p xmlns:a="http://schemas.openxmlformats.org/drawingml/2006/main">
@@ -8250,7 +8284,24 @@
                   <a:srgbClr val="0F172A"/>
                 </a:solidFill>
               </a:rPr>
-              <a:t>Because the impact is broad, backup the workbook and confirm data types before replacement.</a:t>
+              <a:t>Because the impact is broad, backup the workbook</a:t>
+            </a:r>
+          </a:p>
+          <a:p xmlns:a="http://schemas.openxmlformats.org/drawingml/2006/main">
+            <a:pPr algn="l">
+              <a:defRPr sz="1088" b="0">
+                <a:solidFill>
+                  <a:srgbClr val="0F172A"/>
+                </a:solidFill>
+              </a:defRPr>
+            </a:pPr>
+            <a:r>
+              <a:rPr sz="1088" b="0">
+                <a:solidFill>
+                  <a:srgbClr val="0F172A"/>
+                </a:solidFill>
+              </a:rPr>
+              <a:t>and confirm data types before replacement.</a:t>
             </a:r>
           </a:p>
         </p:txBody>
@@ -8264,7 +8315,7 @@
           <p:nvPr/>
         </p:nvPicPr>
         <p:blipFill>
-          <a:blip xmlns:r="http://schemas.openxmlformats.org/officeDocument/2006/relationships" xmlns:a="http://schemas.openxmlformats.org/drawingml/2006/main" r:embed="R70964d2148f04e8a"/>
+          <a:blip xmlns:r="http://schemas.openxmlformats.org/officeDocument/2006/relationships" xmlns:a="http://schemas.openxmlformats.org/drawingml/2006/main" r:embed="R972690e57b5340ea"/>
           <a:stretch xmlns:a="http://schemas.openxmlformats.org/drawingml/2006/main"/>
         </p:blipFill>
         <p:spPr>
@@ -8286,7 +8337,7 @@
           <p:nvPr/>
         </p:nvPicPr>
         <p:blipFill>
-          <a:blip xmlns:r="http://schemas.openxmlformats.org/officeDocument/2006/relationships" xmlns:a="http://schemas.openxmlformats.org/drawingml/2006/main" r:embed="Ra2c1e3a7c2dd47f1"/>
+          <a:blip xmlns:r="http://schemas.openxmlformats.org/officeDocument/2006/relationships" xmlns:a="http://schemas.openxmlformats.org/drawingml/2006/main" r:embed="R6d29fbc047f64269"/>
           <a:stretch xmlns:a="http://schemas.openxmlformats.org/drawingml/2006/main"/>
         </p:blipFill>
         <p:spPr>
@@ -8304,7 +8355,7 @@
           <p:cNvPr id="23" name="">
             <a:extLst xmlns:a="http://schemas.openxmlformats.org/drawingml/2006/main">
               <a:ext uri="{FF2B5EF4-FFF2-40B4-BE49-F238E27FC236}">
-                <a16:creationId xmlns:a16="http://schemas.microsoft.com/office/drawing/2014/main" id="{BDB824D1-5D89-45E2-8B1B-8CA75ABBE135}"/>
+                <a16:creationId xmlns:a16="http://schemas.microsoft.com/office/drawing/2014/main" id="{45456D0B-A2B8-4EFD-A120-3A637F03FDE5}"/>
               </a:ext>
             </a:extLst>
           </p:cNvPr>
@@ -8342,14 +8393,14 @@
           <a:lstStyle xmlns:a="http://schemas.openxmlformats.org/drawingml/2006/main"/>
           <a:p xmlns:a="http://schemas.openxmlformats.org/drawingml/2006/main">
             <a:pPr algn="l">
-              <a:defRPr sz="863" b="1">
+              <a:defRPr sz="938" b="1">
                 <a:solidFill>
                   <a:srgbClr val="5B67D8"/>
                 </a:solidFill>
               </a:defRPr>
             </a:pPr>
             <a:r>
-              <a:rPr sz="863" b="1">
+              <a:rPr sz="938" b="1">
                 <a:solidFill>
                   <a:srgbClr val="5B67D8"/>
                 </a:solidFill>
@@ -8364,7 +8415,7 @@
           <p:cNvPr id="24" name="">
             <a:extLst xmlns:a="http://schemas.openxmlformats.org/drawingml/2006/main">
               <a:ext uri="{FF2B5EF4-FFF2-40B4-BE49-F238E27FC236}">
-                <a16:creationId xmlns:a16="http://schemas.microsoft.com/office/drawing/2014/main" id="{73C49E2F-4362-4DAD-8880-5774D3B65834}"/>
+                <a16:creationId xmlns:a16="http://schemas.microsoft.com/office/drawing/2014/main" id="{CBFE2804-7CA9-4556-9453-F37A96AC9620}"/>
               </a:ext>
             </a:extLst>
           </p:cNvPr>
@@ -8402,14 +8453,14 @@
           <a:lstStyle xmlns:a="http://schemas.openxmlformats.org/drawingml/2006/main"/>
           <a:p xmlns:a="http://schemas.openxmlformats.org/drawingml/2006/main">
             <a:pPr algn="l">
-              <a:defRPr sz="863" b="1">
+              <a:defRPr sz="938" b="1">
                 <a:solidFill>
                   <a:srgbClr val="2CB1BC"/>
                 </a:solidFill>
               </a:defRPr>
             </a:pPr>
             <a:r>
-              <a:rPr sz="863" b="1">
+              <a:rPr sz="938" b="1">
                 <a:solidFill>
                   <a:srgbClr val="2CB1BC"/>
                 </a:solidFill>
@@ -8424,19 +8475,19 @@
           <p:cNvPr id="25" name="">
             <a:extLst xmlns:a="http://schemas.openxmlformats.org/drawingml/2006/main">
               <a:ext uri="{FF2B5EF4-FFF2-40B4-BE49-F238E27FC236}">
-                <a16:creationId xmlns:a16="http://schemas.microsoft.com/office/drawing/2014/main" id="{0FC4B46A-08D4-40B2-A09A-771CFDFADB6D}"/>
-              </a:ext>
-            </a:extLst>
-          </p:cNvPr>
-          <p:cNvSpPr>
-            <a:spLocks xmlns:a="http://schemas.openxmlformats.org/drawingml/2006/main" noGrp="1"/>
-          </p:cNvSpPr>
-          <p:nvPr/>
-        </p:nvSpPr>
-        <p:spPr>
-          <a:xfrm xmlns:a="http://schemas.openxmlformats.org/drawingml/2006/main">
-            <a:off x="514350" y="6400800"/>
-            <a:ext cx="8572500" cy="171450"/>
+                <a16:creationId xmlns:a16="http://schemas.microsoft.com/office/drawing/2014/main" id="{F71ABAC9-A865-457B-A9B9-DC71EC245252}"/>
+              </a:ext>
+            </a:extLst>
+          </p:cNvPr>
+          <p:cNvSpPr>
+            <a:spLocks xmlns:a="http://schemas.openxmlformats.org/drawingml/2006/main" noGrp="1"/>
+          </p:cNvSpPr>
+          <p:nvPr/>
+        </p:nvSpPr>
+        <p:spPr>
+          <a:xfrm xmlns:a="http://schemas.openxmlformats.org/drawingml/2006/main">
+            <a:off x="514350" y="6381750"/>
+            <a:ext cx="8763000" cy="190500"/>
           </a:xfrm>
           <a:prstGeom xmlns:a="http://schemas.openxmlformats.org/drawingml/2006/main" prst="rect">
             <a:avLst/>
@@ -8462,14 +8513,14 @@
           <a:lstStyle xmlns:a="http://schemas.openxmlformats.org/drawingml/2006/main"/>
           <a:p xmlns:a="http://schemas.openxmlformats.org/drawingml/2006/main">
             <a:pPr algn="l">
-              <a:defRPr sz="713" b="0">
+              <a:defRPr sz="825" b="0">
                 <a:solidFill>
                   <a:srgbClr val="475569"/>
                 </a:solidFill>
               </a:defRPr>
             </a:pPr>
             <a:r>
-              <a:rPr sz="713" b="0">
+              <a:rPr sz="825" b="0">
                 <a:solidFill>
                   <a:srgbClr val="475569"/>
                 </a:solidFill>
@@ -8484,19 +8535,19 @@
           <p:cNvPr id="26" name="">
             <a:extLst xmlns:a="http://schemas.openxmlformats.org/drawingml/2006/main">
               <a:ext uri="{FF2B5EF4-FFF2-40B4-BE49-F238E27FC236}">
-                <a16:creationId xmlns:a16="http://schemas.microsoft.com/office/drawing/2014/main" id="{51C643B7-21E0-4822-8941-03135460A91A}"/>
-              </a:ext>
-            </a:extLst>
-          </p:cNvPr>
-          <p:cNvSpPr>
-            <a:spLocks xmlns:a="http://schemas.openxmlformats.org/drawingml/2006/main" noGrp="1"/>
-          </p:cNvSpPr>
-          <p:nvPr/>
-        </p:nvSpPr>
-        <p:spPr>
-          <a:xfrm xmlns:a="http://schemas.openxmlformats.org/drawingml/2006/main">
-            <a:off x="11049000" y="6400800"/>
-            <a:ext cx="628650" cy="171450"/>
+                <a16:creationId xmlns:a16="http://schemas.microsoft.com/office/drawing/2014/main" id="{D40056D3-9B91-459B-9CB0-F969570E5E73}"/>
+              </a:ext>
+            </a:extLst>
+          </p:cNvPr>
+          <p:cNvSpPr>
+            <a:spLocks xmlns:a="http://schemas.openxmlformats.org/drawingml/2006/main" noGrp="1"/>
+          </p:cNvSpPr>
+          <p:nvPr/>
+        </p:nvSpPr>
+        <p:spPr>
+          <a:xfrm xmlns:a="http://schemas.openxmlformats.org/drawingml/2006/main">
+            <a:off x="11049000" y="6381750"/>
+            <a:ext cx="628650" cy="190500"/>
           </a:xfrm>
           <a:prstGeom xmlns:a="http://schemas.openxmlformats.org/drawingml/2006/main" prst="rect">
             <a:avLst/>
@@ -8522,14 +8573,14 @@
           <a:lstStyle xmlns:a="http://schemas.openxmlformats.org/drawingml/2006/main"/>
           <a:p xmlns:a="http://schemas.openxmlformats.org/drawingml/2006/main">
             <a:pPr algn="r">
-              <a:defRPr sz="750" b="0">
+              <a:defRPr sz="825" b="0">
                 <a:solidFill>
                   <a:srgbClr val="475569"/>
                 </a:solidFill>
               </a:defRPr>
             </a:pPr>
             <a:r>
-              <a:rPr sz="750" b="0">
+              <a:rPr sz="825" b="0">
                 <a:solidFill>
                   <a:srgbClr val="475569"/>
                 </a:solidFill>
@@ -8542,7 +8593,7 @@
     </p:spTree>
     <p:extLst>
       <p:ext uri="{BB962C8B-B14F-4D97-AF65-F5344CB8AC3E}">
-        <p14:creationId xmlns:p14="http://schemas.microsoft.com/office/powerpoint/2010/main" val="1614596305"/>
+        <p14:creationId xmlns:p14="http://schemas.microsoft.com/office/powerpoint/2010/main" val="1409794470"/>
       </p:ext>
     </p:extLst>
   </p:cSld>
@@ -8573,7 +8624,7 @@
           <p:cNvPr id="1" name="Slide Number Placeholder 5">
             <a:extLst xmlns:a="http://schemas.openxmlformats.org/drawingml/2006/main">
               <a:ext uri="{FF2B5EF4-FFF2-40B4-BE49-F238E27FC236}">
-                <a16:creationId xmlns:a16="http://schemas.microsoft.com/office/drawing/2014/main" id="{77E5BACE-2531-45AD-B881-6DA5945DE19E}"/>
+                <a16:creationId xmlns:a16="http://schemas.microsoft.com/office/drawing/2014/main" id="{9E5C9098-3215-4B71-A866-2C5144D0CBAB}"/>
               </a:ext>
             </a:extLst>
           </p:cNvPr>
@@ -8605,7 +8656,7 @@
           <p:cNvPr id="2" name="">
             <a:extLst xmlns:a="http://schemas.openxmlformats.org/drawingml/2006/main">
               <a:ext uri="{FF2B5EF4-FFF2-40B4-BE49-F238E27FC236}">
-                <a16:creationId xmlns:a16="http://schemas.microsoft.com/office/drawing/2014/main" id="{0559FBF8-9E9C-49C3-BB1C-77B256359A21}"/>
+                <a16:creationId xmlns:a16="http://schemas.microsoft.com/office/drawing/2014/main" id="{E37BD36B-6D39-4AF0-9828-640DCDA97A53}"/>
               </a:ext>
             </a:extLst>
           </p:cNvPr>
@@ -8638,7 +8689,7 @@
           <p:cNvPr id="3" name="">
             <a:extLst xmlns:a="http://schemas.openxmlformats.org/drawingml/2006/main">
               <a:ext uri="{FF2B5EF4-FFF2-40B4-BE49-F238E27FC236}">
-                <a16:creationId xmlns:a16="http://schemas.microsoft.com/office/drawing/2014/main" id="{5BE40402-98EB-432A-AB44-2C94BD6D2087}"/>
+                <a16:creationId xmlns:a16="http://schemas.microsoft.com/office/drawing/2014/main" id="{4BAE3493-5639-4181-94D8-B7BF5511C3A9}"/>
               </a:ext>
             </a:extLst>
           </p:cNvPr>
@@ -8671,7 +8722,7 @@
           <p:cNvPr id="4" name="">
             <a:extLst xmlns:a="http://schemas.openxmlformats.org/drawingml/2006/main">
               <a:ext uri="{FF2B5EF4-FFF2-40B4-BE49-F238E27FC236}">
-                <a16:creationId xmlns:a16="http://schemas.microsoft.com/office/drawing/2014/main" id="{D1A40118-BA52-4559-BF13-879EA53760DC}"/>
+                <a16:creationId xmlns:a16="http://schemas.microsoft.com/office/drawing/2014/main" id="{9D64E588-AACF-438A-97FC-C244AF97E1F5}"/>
               </a:ext>
             </a:extLst>
           </p:cNvPr>
@@ -8731,7 +8782,7 @@
           <p:cNvPr id="5" name="">
             <a:extLst xmlns:a="http://schemas.openxmlformats.org/drawingml/2006/main">
               <a:ext uri="{FF2B5EF4-FFF2-40B4-BE49-F238E27FC236}">
-                <a16:creationId xmlns:a16="http://schemas.microsoft.com/office/drawing/2014/main" id="{0346B75A-8B13-42B1-A4FF-78BEF9BFDB80}"/>
+                <a16:creationId xmlns:a16="http://schemas.microsoft.com/office/drawing/2014/main" id="{E135EC90-B1C7-4358-A8E4-3C608D064137}"/>
               </a:ext>
             </a:extLst>
           </p:cNvPr>
@@ -8791,7 +8842,7 @@
           <p:cNvPr id="6" name="">
             <a:extLst xmlns:a="http://schemas.openxmlformats.org/drawingml/2006/main">
               <a:ext uri="{FF2B5EF4-FFF2-40B4-BE49-F238E27FC236}">
-                <a16:creationId xmlns:a16="http://schemas.microsoft.com/office/drawing/2014/main" id="{5329465A-E3C7-45E1-81A5-7397365B6909}"/>
+                <a16:creationId xmlns:a16="http://schemas.microsoft.com/office/drawing/2014/main" id="{EE1E0EE8-58C7-49E9-94F0-5C3BC49EEAB3}"/>
               </a:ext>
             </a:extLst>
           </p:cNvPr>
@@ -8851,7 +8902,7 @@
           <p:cNvPr id="7" name="">
             <a:extLst xmlns:a="http://schemas.openxmlformats.org/drawingml/2006/main">
               <a:ext uri="{FF2B5EF4-FFF2-40B4-BE49-F238E27FC236}">
-                <a16:creationId xmlns:a16="http://schemas.microsoft.com/office/drawing/2014/main" id="{133F3D87-036D-4274-A2C2-96CF5CCFDB1F}"/>
+                <a16:creationId xmlns:a16="http://schemas.microsoft.com/office/drawing/2014/main" id="{A52137C3-5F8C-445B-9DEB-43E20D4AA06B}"/>
               </a:ext>
             </a:extLst>
           </p:cNvPr>
@@ -8886,7 +8937,7 @@
           <p:cNvPr id="8" name="">
             <a:extLst xmlns:a="http://schemas.openxmlformats.org/drawingml/2006/main">
               <a:ext uri="{FF2B5EF4-FFF2-40B4-BE49-F238E27FC236}">
-                <a16:creationId xmlns:a16="http://schemas.microsoft.com/office/drawing/2014/main" id="{62EDF14D-EE8B-4ED6-AE8C-9BE5BA09BB08}"/>
+                <a16:creationId xmlns:a16="http://schemas.microsoft.com/office/drawing/2014/main" id="{23E26AA4-79FC-4669-BFB6-FB63BED47875}"/>
               </a:ext>
             </a:extLst>
           </p:cNvPr>
@@ -8919,7 +8970,7 @@
           <p:cNvPr id="9" name="">
             <a:extLst xmlns:a="http://schemas.openxmlformats.org/drawingml/2006/main">
               <a:ext uri="{FF2B5EF4-FFF2-40B4-BE49-F238E27FC236}">
-                <a16:creationId xmlns:a16="http://schemas.microsoft.com/office/drawing/2014/main" id="{F0AB64BB-5BDB-4387-9A79-4FA007D1934A}"/>
+                <a16:creationId xmlns:a16="http://schemas.microsoft.com/office/drawing/2014/main" id="{DA50F2B1-06F7-4A6F-A083-2C880C5D11A4}"/>
               </a:ext>
             </a:extLst>
           </p:cNvPr>
@@ -8979,7 +9030,7 @@
           <p:cNvPr id="10" name="">
             <a:extLst xmlns:a="http://schemas.openxmlformats.org/drawingml/2006/main">
               <a:ext uri="{FF2B5EF4-FFF2-40B4-BE49-F238E27FC236}">
-                <a16:creationId xmlns:a16="http://schemas.microsoft.com/office/drawing/2014/main" id="{E269F409-D273-4BCC-AF7F-F54664BF7B75}"/>
+                <a16:creationId xmlns:a16="http://schemas.microsoft.com/office/drawing/2014/main" id="{ADC4AB71-BC23-4783-9581-F7C4FFCF7055}"/>
               </a:ext>
             </a:extLst>
           </p:cNvPr>
@@ -9039,7 +9090,7 @@
           <p:cNvPr id="11" name="">
             <a:extLst xmlns:a="http://schemas.openxmlformats.org/drawingml/2006/main">
               <a:ext uri="{FF2B5EF4-FFF2-40B4-BE49-F238E27FC236}">
-                <a16:creationId xmlns:a16="http://schemas.microsoft.com/office/drawing/2014/main" id="{88207931-9D92-411A-9B12-E54A1BC3A801}"/>
+                <a16:creationId xmlns:a16="http://schemas.microsoft.com/office/drawing/2014/main" id="{4A852C4A-8B79-4B3A-B537-77FD34853D4B}"/>
               </a:ext>
             </a:extLst>
           </p:cNvPr>
@@ -9074,7 +9125,7 @@
           <p:cNvPr id="12" name="">
             <a:extLst xmlns:a="http://schemas.openxmlformats.org/drawingml/2006/main">
               <a:ext uri="{FF2B5EF4-FFF2-40B4-BE49-F238E27FC236}">
-                <a16:creationId xmlns:a16="http://schemas.microsoft.com/office/drawing/2014/main" id="{12EB916D-F5F8-4DB7-8CEE-E70BD18F8EC0}"/>
+                <a16:creationId xmlns:a16="http://schemas.microsoft.com/office/drawing/2014/main" id="{3C5D11D5-AE53-486C-83E0-1FE47952DCD9}"/>
               </a:ext>
             </a:extLst>
           </p:cNvPr>
@@ -9107,7 +9158,7 @@
           <p:cNvPr id="13" name="">
             <a:extLst xmlns:a="http://schemas.openxmlformats.org/drawingml/2006/main">
               <a:ext uri="{FF2B5EF4-FFF2-40B4-BE49-F238E27FC236}">
-                <a16:creationId xmlns:a16="http://schemas.microsoft.com/office/drawing/2014/main" id="{198BFFF1-F309-4E72-A982-63807EF85FC7}"/>
+                <a16:creationId xmlns:a16="http://schemas.microsoft.com/office/drawing/2014/main" id="{F38F41FA-1E4A-4A2E-B9A3-E073CECAC374}"/>
               </a:ext>
             </a:extLst>
           </p:cNvPr>
@@ -9167,7 +9218,7 @@
           <p:cNvPr id="14" name="">
             <a:extLst xmlns:a="http://schemas.openxmlformats.org/drawingml/2006/main">
               <a:ext uri="{FF2B5EF4-FFF2-40B4-BE49-F238E27FC236}">
-                <a16:creationId xmlns:a16="http://schemas.microsoft.com/office/drawing/2014/main" id="{F29EE11A-EF48-4A3F-891E-469C7B94D336}"/>
+                <a16:creationId xmlns:a16="http://schemas.microsoft.com/office/drawing/2014/main" id="{9685A9C3-5FB8-4AC1-9175-4366DE63E224}"/>
               </a:ext>
             </a:extLst>
           </p:cNvPr>
@@ -9227,7 +9278,7 @@
           <p:cNvPr id="15" name="">
             <a:extLst xmlns:a="http://schemas.openxmlformats.org/drawingml/2006/main">
               <a:ext uri="{FF2B5EF4-FFF2-40B4-BE49-F238E27FC236}">
-                <a16:creationId xmlns:a16="http://schemas.microsoft.com/office/drawing/2014/main" id="{82D1BEC6-D355-411E-9C86-DDFABDA041F6}"/>
+                <a16:creationId xmlns:a16="http://schemas.microsoft.com/office/drawing/2014/main" id="{C5D34314-1F4D-4468-96FB-E6F6B84DDE01}"/>
               </a:ext>
             </a:extLst>
           </p:cNvPr>
@@ -9262,7 +9313,7 @@
           <p:cNvPr id="16" name="">
             <a:extLst xmlns:a="http://schemas.openxmlformats.org/drawingml/2006/main">
               <a:ext uri="{FF2B5EF4-FFF2-40B4-BE49-F238E27FC236}">
-                <a16:creationId xmlns:a16="http://schemas.microsoft.com/office/drawing/2014/main" id="{18B267CC-2B41-4097-BB0D-314830B94080}"/>
+                <a16:creationId xmlns:a16="http://schemas.microsoft.com/office/drawing/2014/main" id="{6F7EDC4E-7457-40CE-B9A3-8C3480BB5337}"/>
               </a:ext>
             </a:extLst>
           </p:cNvPr>
@@ -9295,7 +9346,7 @@
           <p:cNvPr id="17" name="">
             <a:extLst xmlns:a="http://schemas.openxmlformats.org/drawingml/2006/main">
               <a:ext uri="{FF2B5EF4-FFF2-40B4-BE49-F238E27FC236}">
-                <a16:creationId xmlns:a16="http://schemas.microsoft.com/office/drawing/2014/main" id="{88F98CB6-FAE7-4CEE-B793-CE1CB8B6C70D}"/>
+                <a16:creationId xmlns:a16="http://schemas.microsoft.com/office/drawing/2014/main" id="{612FB3B8-8641-417C-BA96-11F6D71AB255}"/>
               </a:ext>
             </a:extLst>
           </p:cNvPr>
@@ -9355,7 +9406,7 @@
           <p:cNvPr id="18" name="">
             <a:extLst xmlns:a="http://schemas.openxmlformats.org/drawingml/2006/main">
               <a:ext uri="{FF2B5EF4-FFF2-40B4-BE49-F238E27FC236}">
-                <a16:creationId xmlns:a16="http://schemas.microsoft.com/office/drawing/2014/main" id="{5485AD50-A9FB-43DB-891E-08E6D9E4BC98}"/>
+                <a16:creationId xmlns:a16="http://schemas.microsoft.com/office/drawing/2014/main" id="{D5C521E5-0B91-4305-841F-04AF6A14CA90}"/>
               </a:ext>
             </a:extLst>
           </p:cNvPr>
@@ -9415,7 +9466,7 @@
           <p:cNvPr id="19" name="">
             <a:extLst xmlns:a="http://schemas.openxmlformats.org/drawingml/2006/main">
               <a:ext uri="{FF2B5EF4-FFF2-40B4-BE49-F238E27FC236}">
-                <a16:creationId xmlns:a16="http://schemas.microsoft.com/office/drawing/2014/main" id="{83099768-EB6C-4128-BD19-CA5849CDFCAD}"/>
+                <a16:creationId xmlns:a16="http://schemas.microsoft.com/office/drawing/2014/main" id="{33402F62-FD80-42BB-B82E-E4A5324F939D}"/>
               </a:ext>
             </a:extLst>
           </p:cNvPr>
@@ -9450,7 +9501,7 @@
           <p:cNvPr id="20" name="">
             <a:extLst xmlns:a="http://schemas.openxmlformats.org/drawingml/2006/main">
               <a:ext uri="{FF2B5EF4-FFF2-40B4-BE49-F238E27FC236}">
-                <a16:creationId xmlns:a16="http://schemas.microsoft.com/office/drawing/2014/main" id="{88CC3240-DDC3-40E1-B090-ED0B9F4807B5}"/>
+                <a16:creationId xmlns:a16="http://schemas.microsoft.com/office/drawing/2014/main" id="{C65794DC-A913-48BD-9116-5291D5C4234B}"/>
               </a:ext>
             </a:extLst>
           </p:cNvPr>
@@ -9510,19 +9561,19 @@
           <p:cNvPr id="21" name="">
             <a:extLst xmlns:a="http://schemas.openxmlformats.org/drawingml/2006/main">
               <a:ext uri="{FF2B5EF4-FFF2-40B4-BE49-F238E27FC236}">
-                <a16:creationId xmlns:a16="http://schemas.microsoft.com/office/drawing/2014/main" id="{CBE91831-F65A-4490-BA0C-4034F0525920}"/>
-              </a:ext>
-            </a:extLst>
-          </p:cNvPr>
-          <p:cNvSpPr>
-            <a:spLocks xmlns:a="http://schemas.openxmlformats.org/drawingml/2006/main" noGrp="1"/>
-          </p:cNvSpPr>
-          <p:nvPr/>
-        </p:nvSpPr>
-        <p:spPr>
-          <a:xfrm xmlns:a="http://schemas.openxmlformats.org/drawingml/2006/main">
-            <a:off x="514350" y="6400800"/>
-            <a:ext cx="8572500" cy="171450"/>
+                <a16:creationId xmlns:a16="http://schemas.microsoft.com/office/drawing/2014/main" id="{A3C85BEF-B719-4C16-A2D6-D390B7CEBC0E}"/>
+              </a:ext>
+            </a:extLst>
+          </p:cNvPr>
+          <p:cNvSpPr>
+            <a:spLocks xmlns:a="http://schemas.openxmlformats.org/drawingml/2006/main" noGrp="1"/>
+          </p:cNvSpPr>
+          <p:nvPr/>
+        </p:nvSpPr>
+        <p:spPr>
+          <a:xfrm xmlns:a="http://schemas.openxmlformats.org/drawingml/2006/main">
+            <a:off x="514350" y="6381750"/>
+            <a:ext cx="8763000" cy="190500"/>
           </a:xfrm>
           <a:prstGeom xmlns:a="http://schemas.openxmlformats.org/drawingml/2006/main" prst="rect">
             <a:avLst/>
@@ -9548,14 +9599,14 @@
           <a:lstStyle xmlns:a="http://schemas.openxmlformats.org/drawingml/2006/main"/>
           <a:p xmlns:a="http://schemas.openxmlformats.org/drawingml/2006/main">
             <a:pPr algn="l">
-              <a:defRPr sz="713" b="0">
+              <a:defRPr sz="825" b="0">
                 <a:solidFill>
                   <a:srgbClr val="475569"/>
                 </a:solidFill>
               </a:defRPr>
             </a:pPr>
             <a:r>
-              <a:rPr sz="713" b="0">
+              <a:rPr sz="825" b="0">
                 <a:solidFill>
                   <a:srgbClr val="475569"/>
                 </a:solidFill>
@@ -9570,19 +9621,19 @@
           <p:cNvPr id="22" name="">
             <a:extLst xmlns:a="http://schemas.openxmlformats.org/drawingml/2006/main">
               <a:ext uri="{FF2B5EF4-FFF2-40B4-BE49-F238E27FC236}">
-                <a16:creationId xmlns:a16="http://schemas.microsoft.com/office/drawing/2014/main" id="{49A10355-1D79-402D-B1BE-B9A7EFA7D70D}"/>
-              </a:ext>
-            </a:extLst>
-          </p:cNvPr>
-          <p:cNvSpPr>
-            <a:spLocks xmlns:a="http://schemas.openxmlformats.org/drawingml/2006/main" noGrp="1"/>
-          </p:cNvSpPr>
-          <p:nvPr/>
-        </p:nvSpPr>
-        <p:spPr>
-          <a:xfrm xmlns:a="http://schemas.openxmlformats.org/drawingml/2006/main">
-            <a:off x="11049000" y="6400800"/>
-            <a:ext cx="628650" cy="171450"/>
+                <a16:creationId xmlns:a16="http://schemas.microsoft.com/office/drawing/2014/main" id="{F80F3477-896B-402F-A5B5-9180B792DAF9}"/>
+              </a:ext>
+            </a:extLst>
+          </p:cNvPr>
+          <p:cNvSpPr>
+            <a:spLocks xmlns:a="http://schemas.openxmlformats.org/drawingml/2006/main" noGrp="1"/>
+          </p:cNvSpPr>
+          <p:nvPr/>
+        </p:nvSpPr>
+        <p:spPr>
+          <a:xfrm xmlns:a="http://schemas.openxmlformats.org/drawingml/2006/main">
+            <a:off x="11049000" y="6381750"/>
+            <a:ext cx="628650" cy="190500"/>
           </a:xfrm>
           <a:prstGeom xmlns:a="http://schemas.openxmlformats.org/drawingml/2006/main" prst="rect">
             <a:avLst/>
@@ -9608,14 +9659,14 @@
           <a:lstStyle xmlns:a="http://schemas.openxmlformats.org/drawingml/2006/main"/>
           <a:p xmlns:a="http://schemas.openxmlformats.org/drawingml/2006/main">
             <a:pPr algn="r">
-              <a:defRPr sz="750" b="0">
+              <a:defRPr sz="825" b="0">
                 <a:solidFill>
                   <a:srgbClr val="475569"/>
                 </a:solidFill>
               </a:defRPr>
             </a:pPr>
             <a:r>
-              <a:rPr sz="750" b="0">
+              <a:rPr sz="825" b="0">
                 <a:solidFill>
                   <a:srgbClr val="475569"/>
                 </a:solidFill>
@@ -9628,7 +9679,7 @@
     </p:spTree>
     <p:extLst>
       <p:ext uri="{BB962C8B-B14F-4D97-AF65-F5344CB8AC3E}">
-        <p14:creationId xmlns:p14="http://schemas.microsoft.com/office/powerpoint/2010/main" val="217865008"/>
+        <p14:creationId xmlns:p14="http://schemas.microsoft.com/office/powerpoint/2010/main" val="1090240384"/>
       </p:ext>
     </p:extLst>
   </p:cSld>

</xml_diff>